<commit_message>
Redesign the SIH idea presentation
- Idea slide: shorter points, dashboard screenshot, headline results as stat tiles
- Feasibility slide: per-dataset results chart (forecast and detection vs the baseline) and a
  challenges -> strategies table
- Impact slide: benefit cards, larger screenshot, QR code and link to the demo video
- References slide: grouped references, clickable links and QR codes for the repo and the video
- Document properties now name the team instead of the template's
- Document generator scripts are no longer part of the repository
</commit_message>
<xml_diff>
--- a/docs/VIGHNAX_SIH_Idea_Presentation.pptx
+++ b/docs/VIGHNAX_SIH_Idea_Presentation.pptx
@@ -5954,7 +5954,7 @@
         <p:spPr bwMode="auto">
           <a:xfrm>
             <a:off x="411480" y="1188720"/>
-            <a:ext cx="11338560" cy="5074920"/>
+            <a:ext cx="6949440" cy="5074920"/>
           </a:xfrm>
           <a:prstGeom prst="rect">
             <a:avLst/>
@@ -5978,7 +5978,7 @@
               <a:buChar char="v"/>
             </a:pPr>
             <a:r>
-              <a:rPr sz="1900" b="1">
+              <a:rPr sz="1800" b="1">
                 <a:solidFill>
                   <a:srgbClr val="1F4E9A"/>
                 </a:solidFill>
@@ -6003,7 +6003,7 @@
               <a:buChar char="v"/>
             </a:pPr>
             <a:r>
-              <a:rPr sz="1650" b="1">
+              <a:rPr sz="1550" b="1">
                 <a:solidFill>
                   <a:srgbClr val="1F4E9A"/>
                 </a:solidFill>
@@ -6015,55 +6015,82 @@
           <a:p>
             <a:pPr marL="457200" indent="-228600">
               <a:spcBef>
-                <a:spcPts val="200"/>
+                <a:spcPts val="300"/>
               </a:spcBef>
               <a:buFont typeface="Arial"/>
               <a:buChar char="•"/>
             </a:pPr>
             <a:r>
-              <a:rPr sz="1500" b="0">
+              <a:rPr sz="1350" b="1">
                 <a:solidFill>
                   <a:srgbClr val="202020"/>
                 </a:solidFill>
                 <a:latin typeface="Arial"/>
               </a:rPr>
-              <a:t>A world model (recurrent state-space model) learns how a network's state evolves: every 10 s it reads a 78-feature state built from flow records and/or packet captures</a:t>
+              <a:t>A world model of the network: </a:t>
+            </a:r>
+            <a:r>
+              <a:rPr sz="1350" b="0">
+                <a:solidFill>
+                  <a:srgbClr val="202020"/>
+                </a:solidFill>
+                <a:latin typeface="Arial"/>
+              </a:rPr>
+              <a:t>every 10 s it reads a 78-feature state from flow records and/or packets</a:t>
             </a:r>
           </a:p>
           <a:p>
             <a:pPr marL="457200" indent="-228600">
               <a:spcBef>
-                <a:spcPts val="200"/>
+                <a:spcPts val="300"/>
               </a:spcBef>
               <a:buFont typeface="Arial"/>
               <a:buChar char="•"/>
             </a:pPr>
             <a:r>
-              <a:rPr sz="1500" b="0">
+              <a:rPr sz="1350" b="1">
                 <a:solidFill>
                   <a:srgbClr val="202020"/>
                 </a:solidFill>
                 <a:latin typeface="Arial"/>
               </a:rPr>
-              <a:t>It simulates 32 possible futures 60 s ahead: the probability that an attack is about to progress, with an uncertainty band, and the MITRE ATT&amp;CK stage it is heading to</a:t>
+              <a:t>Simulates 32 futures, 60 s ahead: </a:t>
+            </a:r>
+            <a:r>
+              <a:rPr sz="1350" b="0">
+                <a:solidFill>
+                  <a:srgbClr val="202020"/>
+                </a:solidFill>
+                <a:latin typeface="Arial"/>
+              </a:rPr>
+              <a:t>attack probability with an uncertainty band, and the next MITRE ATT&amp;CK stage</a:t>
             </a:r>
           </a:p>
           <a:p>
             <a:pPr marL="457200" indent="-228600">
               <a:spcBef>
-                <a:spcPts val="200"/>
+                <a:spcPts val="300"/>
               </a:spcBef>
               <a:buFont typeface="Arial"/>
               <a:buChar char="•"/>
             </a:pPr>
             <a:r>
-              <a:rPr sz="1500" b="0">
+              <a:rPr sz="1350" b="1">
                 <a:solidFill>
                   <a:srgbClr val="202020"/>
                 </a:solidFill>
                 <a:latin typeface="Arial"/>
               </a:rPr>
-              <a:t>Every alert is explained (Integrated Gradients) and traced to the responsible hosts and flows; working prototype: offline dashboard, PCAP / NetFlow-style CSV in, forecasts out, window by window</a:t>
+              <a:t>Explains every alert: </a:t>
+            </a:r>
+            <a:r>
+              <a:rPr sz="1350" b="0">
+                <a:solidFill>
+                  <a:srgbClr val="202020"/>
+                </a:solidFill>
+                <a:latin typeface="Arial"/>
+              </a:rPr>
+              <a:t>Integrated Gradients, plus the hosts and flows responsible</a:t>
             </a:r>
           </a:p>
           <a:p>
@@ -6075,7 +6102,7 @@
               <a:buChar char="v"/>
             </a:pPr>
             <a:r>
-              <a:rPr sz="1650" b="1">
+              <a:rPr sz="1550" b="1">
                 <a:solidFill>
                   <a:srgbClr val="1F4E9A"/>
                 </a:solidFill>
@@ -6087,37 +6114,55 @@
           <a:p>
             <a:pPr marL="457200" indent="-228600">
               <a:spcBef>
-                <a:spcPts val="200"/>
+                <a:spcPts val="300"/>
               </a:spcBef>
               <a:buFont typeface="Arial"/>
               <a:buChar char="•"/>
             </a:pPr>
             <a:r>
-              <a:rPr sz="1500" b="0">
+              <a:rPr sz="1350" b="1">
                 <a:solidFill>
                   <a:srgbClr val="202020"/>
                 </a:solidFill>
                 <a:latin typeface="Arial"/>
               </a:rPr>
-              <a:t>Moves from detection after the fact to early warning: 54 of 201 attack onsets in unseen test traffic were forecast before they began (logistic-regression baseline: 17)</a:t>
+              <a:t>Early warning, not after-the-fact detection: </a:t>
+            </a:r>
+            <a:r>
+              <a:rPr sz="1350" b="0">
+                <a:solidFill>
+                  <a:srgbClr val="202020"/>
+                </a:solidFill>
+                <a:latin typeface="Arial"/>
+              </a:rPr>
+              <a:t>54 of 201 unseen attack onsets forecast before they began (baseline: 17)</a:t>
             </a:r>
           </a:p>
           <a:p>
             <a:pPr marL="457200" indent="-228600">
               <a:spcBef>
-                <a:spcPts val="200"/>
+                <a:spcPts val="300"/>
               </a:spcBef>
               <a:buFont typeface="Arial"/>
               <a:buChar char="•"/>
             </a:pPr>
             <a:r>
-              <a:rPr sz="1500" b="0">
+              <a:rPr sz="1350" b="1">
                 <a:solidFill>
                   <a:srgbClr val="202020"/>
                 </a:solidFill>
                 <a:latin typeface="Arial"/>
               </a:rPr>
-              <a:t>One model trained on all seven datasets named in the PS and tested only on days, captures and botnet families it never saw</a:t>
+              <a:t>One model, all seven PS datasets: </a:t>
+            </a:r>
+            <a:r>
+              <a:rPr sz="1350" b="0">
+                <a:solidFill>
+                  <a:srgbClr val="202020"/>
+                </a:solidFill>
+                <a:latin typeface="Arial"/>
+              </a:rPr>
+              <a:t>tested only on days, captures and botnets it never saw</a:t>
             </a:r>
           </a:p>
           <a:p>
@@ -6129,7 +6174,7 @@
               <a:buChar char="v"/>
             </a:pPr>
             <a:r>
-              <a:rPr sz="1650" b="1">
+              <a:rPr sz="1550" b="1">
                 <a:solidFill>
                   <a:srgbClr val="1F4E9A"/>
                 </a:solidFill>
@@ -6141,55 +6186,82 @@
           <a:p>
             <a:pPr marL="457200" indent="-228600">
               <a:spcBef>
-                <a:spcPts val="200"/>
+                <a:spcPts val="300"/>
               </a:spcBef>
               <a:buFont typeface="Arial"/>
               <a:buChar char="•"/>
             </a:pPr>
             <a:r>
-              <a:rPr sz="1500" b="0">
+              <a:rPr sz="1350" b="1">
                 <a:solidFill>
                   <a:srgbClr val="202020"/>
                 </a:solidFill>
                 <a:latin typeface="Arial"/>
               </a:rPr>
-              <a:t>Generative 'what-if' simulation of the network instead of a per-flow classifier</a:t>
+              <a:t>'What-if' simulation </a:t>
+            </a:r>
+            <a:r>
+              <a:rPr sz="1350" b="0">
+                <a:solidFill>
+                  <a:srgbClr val="202020"/>
+                </a:solidFill>
+                <a:latin typeface="Arial"/>
+              </a:rPr>
+              <a:t>of the whole network, not a per-flow classifier</a:t>
             </a:r>
           </a:p>
           <a:p>
             <a:pPr marL="457200" indent="-228600">
               <a:spcBef>
-                <a:spcPts val="200"/>
+                <a:spcPts val="300"/>
               </a:spcBef>
               <a:buFont typeface="Arial"/>
               <a:buChar char="•"/>
             </a:pPr>
             <a:r>
-              <a:rPr sz="1500" b="0">
+              <a:rPr sz="1350" b="1">
                 <a:solidFill>
                   <a:srgbClr val="202020"/>
                 </a:solidFill>
                 <a:latin typeface="Arial"/>
               </a:rPr>
-              <a:t>Answers who, not only what: removing each host and re-running the forecast ranks the hosts behind an alert</a:t>
+              <a:t>Answers who, not only what: </a:t>
+            </a:r>
+            <a:r>
+              <a:rPr sz="1350" b="0">
+                <a:solidFill>
+                  <a:srgbClr val="202020"/>
+                </a:solidFill>
+                <a:latin typeface="Arial"/>
+              </a:rPr>
+              <a:t>re-forecasting without each host ranks the hosts behind an alert</a:t>
             </a:r>
           </a:p>
           <a:p>
             <a:pPr marL="457200" indent="-228600">
               <a:spcBef>
-                <a:spcPts val="200"/>
+                <a:spcPts val="300"/>
               </a:spcBef>
               <a:buFont typeface="Arial"/>
               <a:buChar char="•"/>
             </a:pPr>
             <a:r>
-              <a:rPr sz="1500" b="0">
+              <a:rPr sz="1350" b="1">
                 <a:solidFill>
                   <a:srgbClr val="202020"/>
                 </a:solidFill>
                 <a:latin typeface="Arial"/>
               </a:rPr>
-              <a:t>Air-gap ready: runs fully offline on a laptop CPU, SHA-256-verified model weights, one-click incident report</a:t>
+              <a:t>Air-gap ready: </a:t>
+            </a:r>
+            <a:r>
+              <a:rPr sz="1350" b="0">
+                <a:solidFill>
+                  <a:srgbClr val="202020"/>
+                </a:solidFill>
+                <a:latin typeface="Arial"/>
+              </a:rPr>
+              <a:t>laptop CPU, SHA-256-verified weights, one-click incident report</a:t>
             </a:r>
           </a:p>
         </p:txBody>
@@ -6346,6 +6418,294 @@
           </a:prstGeom>
         </p:spPr>
       </p:pic>
+      <p:pic>
+        <p:nvPicPr>
+          <p:cNvPr id="15363" name="Picture 15362" descr="dashboard_dark.png"/>
+          <p:cNvPicPr>
+            <a:picLocks noChangeAspect="1"/>
+          </p:cNvPicPr>
+          <p:nvPr/>
+        </p:nvPicPr>
+        <p:blipFill>
+          <a:blip r:embed="rId4"/>
+          <a:stretch>
+            <a:fillRect/>
+          </a:stretch>
+        </p:blipFill>
+        <p:spPr>
+          <a:xfrm>
+            <a:off x="7589520" y="1280160"/>
+            <a:ext cx="4251960" cy="2291334"/>
+          </a:xfrm>
+          <a:prstGeom prst="rect">
+            <a:avLst/>
+          </a:prstGeom>
+          <a:ln w="9525">
+            <a:solidFill>
+              <a:srgbClr val="C9D3E3"/>
+            </a:solidFill>
+          </a:ln>
+        </p:spPr>
+      </p:pic>
+      <p:sp>
+        <p:nvSpPr>
+          <p:cNvPr id="15364" name="TextBox 15363"/>
+          <p:cNvSpPr txBox="1"/>
+          <p:nvPr/>
+        </p:nvSpPr>
+        <p:spPr>
+          <a:xfrm>
+            <a:off x="7589520" y="3617214"/>
+            <a:ext cx="4251960" cy="502920"/>
+          </a:xfrm>
+          <a:prstGeom prst="rect">
+            <a:avLst/>
+          </a:prstGeom>
+          <a:noFill/>
+        </p:spPr>
+        <p:txBody>
+          <a:bodyPr wrap="square">
+            <a:spAutoFit/>
+          </a:bodyPr>
+          <a:lstStyle/>
+          <a:p>
+            <a:pPr marL="0" indent="0">
+              <a:buNone/>
+            </a:pPr>
+            <a:r>
+              <a:rPr sz="1000" b="0">
+                <a:solidFill>
+                  <a:srgbClr val="555555"/>
+                </a:solidFill>
+                <a:latin typeface="Arial"/>
+              </a:rPr>
+              <a:t>Working prototype on an unseen CIC-IDS2017 day: risk turns critical as the DDoS begins.</a:t>
+            </a:r>
+          </a:p>
+        </p:txBody>
+      </p:sp>
+      <p:sp>
+        <p:nvSpPr>
+          <p:cNvPr id="15365" name="Rounded Rectangle 15364"/>
+          <p:cNvSpPr/>
+          <p:nvPr/>
+        </p:nvSpPr>
+        <p:spPr>
+          <a:xfrm>
+            <a:off x="7589520" y="4343400"/>
+            <a:ext cx="1344168" cy="1554480"/>
+          </a:xfrm>
+          <a:prstGeom prst="roundRect">
+            <a:avLst>
+              <a:gd name="adj" fmla="val 7000"/>
+            </a:avLst>
+          </a:prstGeom>
+          <a:solidFill>
+            <a:srgbClr val="EEF3FA"/>
+          </a:solidFill>
+          <a:ln>
+            <a:noFill/>
+          </a:ln>
+          <a:effectLst/>
+        </p:spPr>
+        <p:style>
+          <a:lnRef idx="1">
+            <a:schemeClr val="accent1"/>
+          </a:lnRef>
+          <a:fillRef idx="3">
+            <a:schemeClr val="accent1"/>
+          </a:fillRef>
+          <a:effectRef idx="2">
+            <a:schemeClr val="accent1"/>
+          </a:effectRef>
+          <a:fontRef idx="minor">
+            <a:schemeClr val="lt1"/>
+          </a:fontRef>
+        </p:style>
+        <p:txBody>
+          <a:bodyPr rtlCol="0" anchor="ctr" wrap="square" lIns="128016" rIns="128016" tIns="64008" bIns="64008"/>
+          <a:lstStyle/>
+          <a:p>
+            <a:pPr algn="ctr" marL="0" indent="0">
+              <a:buNone/>
+            </a:pPr>
+            <a:r>
+              <a:rPr sz="2400" b="1">
+                <a:solidFill>
+                  <a:srgbClr val="1F4E9A"/>
+                </a:solidFill>
+                <a:latin typeface="Arial"/>
+              </a:rPr>
+              <a:t>54/201</a:t>
+            </a:r>
+          </a:p>
+          <a:p>
+            <a:pPr marL="0" indent="0" algn="ctr">
+              <a:spcBef>
+                <a:spcPts val="200"/>
+              </a:spcBef>
+              <a:buNone/>
+            </a:pPr>
+            <a:r>
+              <a:rPr sz="1050" b="0">
+                <a:solidFill>
+                  <a:srgbClr val="202020"/>
+                </a:solidFill>
+                <a:latin typeface="Arial"/>
+              </a:rPr>
+              <a:t>attack onsets warned before they began</a:t>
+            </a:r>
+          </a:p>
+        </p:txBody>
+      </p:sp>
+      <p:sp>
+        <p:nvSpPr>
+          <p:cNvPr id="15366" name="Rounded Rectangle 15365"/>
+          <p:cNvSpPr/>
+          <p:nvPr/>
+        </p:nvSpPr>
+        <p:spPr>
+          <a:xfrm>
+            <a:off x="9043416" y="4343400"/>
+            <a:ext cx="1344168" cy="1554480"/>
+          </a:xfrm>
+          <a:prstGeom prst="roundRect">
+            <a:avLst>
+              <a:gd name="adj" fmla="val 7000"/>
+            </a:avLst>
+          </a:prstGeom>
+          <a:solidFill>
+            <a:srgbClr val="EEF3FA"/>
+          </a:solidFill>
+          <a:ln>
+            <a:noFill/>
+          </a:ln>
+          <a:effectLst/>
+        </p:spPr>
+        <p:style>
+          <a:lnRef idx="1">
+            <a:schemeClr val="accent1"/>
+          </a:lnRef>
+          <a:fillRef idx="3">
+            <a:schemeClr val="accent1"/>
+          </a:fillRef>
+          <a:effectRef idx="2">
+            <a:schemeClr val="accent1"/>
+          </a:effectRef>
+          <a:fontRef idx="minor">
+            <a:schemeClr val="lt1"/>
+          </a:fontRef>
+        </p:style>
+        <p:txBody>
+          <a:bodyPr rtlCol="0" anchor="ctr" wrap="square" lIns="128016" rIns="128016" tIns="64008" bIns="64008"/>
+          <a:lstStyle/>
+          <a:p>
+            <a:pPr algn="ctr" marL="0" indent="0">
+              <a:buNone/>
+            </a:pPr>
+            <a:r>
+              <a:rPr sz="2400" b="1">
+                <a:solidFill>
+                  <a:srgbClr val="1F4E9A"/>
+                </a:solidFill>
+                <a:latin typeface="Arial"/>
+              </a:rPr>
+              <a:t>3.2×</a:t>
+            </a:r>
+          </a:p>
+          <a:p>
+            <a:pPr marL="0" indent="0" algn="ctr">
+              <a:spcBef>
+                <a:spcPts val="200"/>
+              </a:spcBef>
+              <a:buNone/>
+            </a:pPr>
+            <a:r>
+              <a:rPr sz="1050" b="0">
+                <a:solidFill>
+                  <a:srgbClr val="202020"/>
+                </a:solidFill>
+                <a:latin typeface="Arial"/>
+              </a:rPr>
+              <a:t>more early warnings than the baseline (17)</a:t>
+            </a:r>
+          </a:p>
+        </p:txBody>
+      </p:sp>
+      <p:sp>
+        <p:nvSpPr>
+          <p:cNvPr id="15367" name="Rounded Rectangle 15366"/>
+          <p:cNvSpPr/>
+          <p:nvPr/>
+        </p:nvSpPr>
+        <p:spPr>
+          <a:xfrm>
+            <a:off x="10497312" y="4343400"/>
+            <a:ext cx="1344168" cy="1554480"/>
+          </a:xfrm>
+          <a:prstGeom prst="roundRect">
+            <a:avLst>
+              <a:gd name="adj" fmla="val 7000"/>
+            </a:avLst>
+          </a:prstGeom>
+          <a:solidFill>
+            <a:srgbClr val="EEF3FA"/>
+          </a:solidFill>
+          <a:ln>
+            <a:noFill/>
+          </a:ln>
+          <a:effectLst/>
+        </p:spPr>
+        <p:style>
+          <a:lnRef idx="1">
+            <a:schemeClr val="accent1"/>
+          </a:lnRef>
+          <a:fillRef idx="3">
+            <a:schemeClr val="accent1"/>
+          </a:fillRef>
+          <a:effectRef idx="2">
+            <a:schemeClr val="accent1"/>
+          </a:effectRef>
+          <a:fontRef idx="minor">
+            <a:schemeClr val="lt1"/>
+          </a:fontRef>
+        </p:style>
+        <p:txBody>
+          <a:bodyPr rtlCol="0" anchor="ctr" wrap="square" lIns="128016" rIns="128016" tIns="64008" bIns="64008"/>
+          <a:lstStyle/>
+          <a:p>
+            <a:pPr algn="ctr" marL="0" indent="0">
+              <a:buNone/>
+            </a:pPr>
+            <a:r>
+              <a:rPr sz="2400" b="1">
+                <a:solidFill>
+                  <a:srgbClr val="1F4E9A"/>
+                </a:solidFill>
+                <a:latin typeface="Arial"/>
+              </a:rPr>
+              <a:t>~8 ms</a:t>
+            </a:r>
+          </a:p>
+          <a:p>
+            <a:pPr marL="0" indent="0" algn="ctr">
+              <a:spcBef>
+                <a:spcPts val="200"/>
+              </a:spcBef>
+              <a:buNone/>
+            </a:pPr>
+            <a:r>
+              <a:rPr sz="1050" b="0">
+                <a:solidFill>
+                  <a:srgbClr val="202020"/>
+                </a:solidFill>
+                <a:latin typeface="Arial"/>
+              </a:rPr>
+              <a:t>per 10 s window on a laptop CPU</a:t>
+            </a:r>
+          </a:p>
+        </p:txBody>
+      </p:sp>
     </p:spTree>
   </p:cSld>
   <p:clrMapOvr>
@@ -6509,7 +6869,7 @@
           <a:p>
             <a:pPr marL="457200" indent="-228600">
               <a:spcBef>
-                <a:spcPts val="200"/>
+                <a:spcPts val="300"/>
               </a:spcBef>
               <a:buFont typeface="Arial"/>
               <a:buChar char="•"/>
@@ -6536,7 +6896,7 @@
           <a:p>
             <a:pPr marL="457200" indent="-228600">
               <a:spcBef>
-                <a:spcPts val="200"/>
+                <a:spcPts val="300"/>
               </a:spcBef>
               <a:buFont typeface="Arial"/>
               <a:buChar char="•"/>
@@ -6563,7 +6923,7 @@
           <a:p>
             <a:pPr marL="457200" indent="-228600">
               <a:spcBef>
-                <a:spcPts val="200"/>
+                <a:spcPts val="300"/>
               </a:spcBef>
               <a:buFont typeface="Arial"/>
               <a:buChar char="•"/>
@@ -6925,7 +7285,7 @@
         <p:spPr bwMode="auto">
           <a:xfrm>
             <a:off x="411480" y="1143000"/>
-            <a:ext cx="6903720" cy="5120640"/>
+            <a:ext cx="5394960" cy="3017520"/>
           </a:xfrm>
           <a:prstGeom prst="rect">
             <a:avLst/>
@@ -6962,7 +7322,7 @@
               <a:defRPr/>
             </a:pPr>
             <a:r>
-              <a:rPr sz="1500" b="1">
+              <a:rPr sz="1550" b="1">
                 <a:solidFill>
                   <a:srgbClr val="1F4E9A"/>
                 </a:solidFill>
@@ -6988,199 +7348,136 @@
           <a:p>
             <a:pPr marL="457200" indent="-228600">
               <a:spcBef>
-                <a:spcPts val="200"/>
+                <a:spcPts val="300"/>
               </a:spcBef>
               <a:buFont typeface="Arial"/>
               <a:buChar char="•"/>
             </a:pPr>
             <a:r>
-              <a:rPr sz="1300" b="0">
+              <a:rPr sz="1350" b="1">
                 <a:solidFill>
                   <a:srgbClr val="202020"/>
                 </a:solidFill>
                 <a:latin typeface="Arial"/>
               </a:rPr>
-              <a:t>Working prototype, trained weights and full benchmark are already built and public on GitHub</a:t>
+              <a:t>Already built: </a:t>
+            </a:r>
+            <a:r>
+              <a:rPr sz="1350" b="0">
+                <a:solidFill>
+                  <a:srgbClr val="202020"/>
+                </a:solidFill>
+                <a:latin typeface="Arial"/>
+              </a:rPr>
+              <a:t>working prototype, trained weights and the full benchmark are public on GitHub</a:t>
             </a:r>
           </a:p>
           <a:p>
             <a:pPr marL="457200" indent="-228600">
               <a:spcBef>
-                <a:spcPts val="200"/>
+                <a:spcPts val="300"/>
               </a:spcBef>
               <a:buFont typeface="Arial"/>
               <a:buChar char="•"/>
             </a:pPr>
             <a:r>
-              <a:rPr sz="1300" b="0">
+              <a:rPr sz="1350" b="1">
                 <a:solidFill>
                   <a:srgbClr val="202020"/>
                 </a:solidFill>
                 <a:latin typeface="Arial"/>
               </a:rPr>
-              <a:t>Unseen test data, macro over six temporal datasets: forecast AUROC 0.70 vs 0.67 (LR), detection 0.74 vs 0.72</a:t>
+              <a:t>Tested on unseen data: </a:t>
+            </a:r>
+            <a:r>
+              <a:rPr sz="1350" b="0">
+                <a:solidFill>
+                  <a:srgbClr val="202020"/>
+                </a:solidFill>
+                <a:latin typeface="Arial"/>
+              </a:rPr>
+              <a:t>macro forecast AUROC 0.70 vs 0.67 for the baseline, detection 0.74 vs 0.72</a:t>
             </a:r>
           </a:p>
           <a:p>
             <a:pPr marL="457200" indent="-228600">
               <a:spcBef>
-                <a:spcPts val="200"/>
+                <a:spcPts val="300"/>
               </a:spcBef>
               <a:buFont typeface="Arial"/>
               <a:buChar char="•"/>
             </a:pPr>
             <a:r>
-              <a:rPr sz="1300" b="0">
+              <a:rPr sz="1350" b="1">
                 <a:solidFill>
                   <a:srgbClr val="202020"/>
                 </a:solidFill>
                 <a:latin typeface="Arial"/>
               </a:rPr>
-              <a:t>Throughput: one laptop CPU core processes traffic over 1,000x faster than real time</a:t>
-            </a:r>
-          </a:p>
-          <a:p>
-            <a:pPr marL="228600" indent="-228600">
-              <a:spcBef>
-                <a:spcPts val="800"/>
-              </a:spcBef>
-              <a:buFont typeface="Wingdings"/>
-              <a:buChar char="v"/>
-            </a:pPr>
-            <a:r>
-              <a:rPr sz="1500" b="1">
-                <a:solidFill>
-                  <a:srgbClr val="1F4E9A"/>
+              <a:t>Fast and light: </a:t>
+            </a:r>
+            <a:r>
+              <a:rPr sz="1350" b="0">
+                <a:solidFill>
+                  <a:srgbClr val="202020"/>
                 </a:solidFill>
                 <a:latin typeface="Arial"/>
               </a:rPr>
-              <a:t>Potential challenges and risks</a:t>
+              <a:t>one laptop CPU core processes traffic over 1,000× faster than real time</a:t>
             </a:r>
           </a:p>
           <a:p>
             <a:pPr marL="457200" indent="-228600">
               <a:spcBef>
-                <a:spcPts val="200"/>
+                <a:spcPts val="300"/>
               </a:spcBef>
               <a:buFont typeface="Arial"/>
               <a:buChar char="•"/>
             </a:pPr>
             <a:r>
-              <a:rPr sz="1300" b="0">
+              <a:rPr sz="1350" b="1">
                 <a:solidFill>
                   <a:srgbClr val="202020"/>
                 </a:solidFill>
                 <a:latin typeface="Arial"/>
               </a:rPr>
-              <a:t>Weak on LANL (authentication-based red team) and behind LR on DARPA 1999; reported openly</a:t>
+              <a:t>Easy to deploy: </a:t>
+            </a:r>
+            <a:r>
+              <a:rPr sz="1350" b="0">
+                <a:solidFill>
+                  <a:srgbClr val="202020"/>
+                </a:solidFill>
+                <a:latin typeface="Arial"/>
+              </a:rPr>
+              <a:t>one-click launch; PCAP or flow CSV in; no GPU, cloud or internet needed</a:t>
             </a:r>
           </a:p>
           <a:p>
             <a:pPr marL="457200" indent="-228600">
               <a:spcBef>
-                <a:spcPts val="200"/>
+                <a:spcPts val="300"/>
               </a:spcBef>
               <a:buFont typeface="Arial"/>
               <a:buChar char="•"/>
             </a:pPr>
             <a:r>
-              <a:rPr sz="1300" b="0">
+              <a:rPr sz="1350" b="1">
                 <a:solidFill>
                   <a:srgbClr val="202020"/>
                 </a:solidFill>
                 <a:latin typeface="Arial"/>
               </a:rPr>
-              <a:t>More false alarms on networks the model was not calibrated on; concept drift over time</a:t>
-            </a:r>
-          </a:p>
-          <a:p>
-            <a:pPr marL="457200" indent="-228600">
-              <a:spcBef>
-                <a:spcPts val="200"/>
-              </a:spcBef>
-              <a:buFont typeface="Arial"/>
-              <a:buChar char="•"/>
-            </a:pPr>
-            <a:r>
-              <a:rPr sz="1300" b="0">
+              <a:t>Honest evaluation: </a:t>
+            </a:r>
+            <a:r>
+              <a:rPr sz="1350" b="0">
                 <a:solidFill>
                   <a:srgbClr val="202020"/>
                 </a:solidFill>
                 <a:latin typeface="Arial"/>
               </a:rPr>
-              <a:t>Encrypted traffic hides payloads</a:t>
-            </a:r>
-          </a:p>
-          <a:p>
-            <a:pPr marL="228600" indent="-228600">
-              <a:spcBef>
-                <a:spcPts val="800"/>
-              </a:spcBef>
-              <a:buFont typeface="Wingdings"/>
-              <a:buChar char="v"/>
-            </a:pPr>
-            <a:r>
-              <a:rPr sz="1500" b="1">
-                <a:solidFill>
-                  <a:srgbClr val="1F4E9A"/>
-                </a:solidFill>
-                <a:latin typeface="Arial"/>
-              </a:rPr>
-              <a:t>Strategies for overcoming these challenges</a:t>
-            </a:r>
-          </a:p>
-          <a:p>
-            <a:pPr marL="457200" indent="-228600">
-              <a:spcBef>
-                <a:spcPts val="200"/>
-              </a:spcBef>
-              <a:buFont typeface="Arial"/>
-              <a:buChar char="•"/>
-            </a:pPr>
-            <a:r>
-              <a:rPr sz="1300" b="0">
-                <a:solidFill>
-                  <a:srgbClr val="202020"/>
-                </a:solidFill>
-                <a:latin typeface="Arial"/>
-              </a:rPr>
-              <a:t>Per-network alert calibration on the site's own traffic (site profiles already built in)</a:t>
-            </a:r>
-          </a:p>
-          <a:p>
-            <a:pPr marL="457200" indent="-228600">
-              <a:spcBef>
-                <a:spcPts val="200"/>
-              </a:spcBef>
-              <a:buFont typeface="Arial"/>
-              <a:buChar char="•"/>
-            </a:pPr>
-            <a:r>
-              <a:rPr sz="1300" b="0">
-                <a:solidFill>
-                  <a:srgbClr val="202020"/>
-                </a:solidFill>
-                <a:latin typeface="Arial"/>
-              </a:rPr>
-              <a:t>Authentication-log and per-host modelling for LANL-type attacks; periodic retraining</a:t>
-            </a:r>
-          </a:p>
-          <a:p>
-            <a:pPr marL="457200" indent="-228600">
-              <a:spcBef>
-                <a:spcPts val="200"/>
-              </a:spcBef>
-              <a:buFont typeface="Arial"/>
-              <a:buChar char="•"/>
-            </a:pPr>
-            <a:r>
-              <a:rPr sz="1300" b="0">
-                <a:solidFill>
-                  <a:srgbClr val="202020"/>
-                </a:solidFill>
-                <a:latin typeface="Arial"/>
-              </a:rPr>
-              <a:t>Flow-level features need no payload, so the model works on encrypted traffic and on flow-only input</a:t>
+              <a:t>scored only on traffic it never saw; weaker results are shown, not hidden</a:t>
             </a:r>
           </a:p>
         </p:txBody>
@@ -7420,17 +7717,78 @@
           </a:prstGeom>
         </p:spPr>
       </p:pic>
+      <p:pic>
+        <p:nvPicPr>
+          <p:cNvPr id="17411" name="Picture 17410" descr="results.png"/>
+          <p:cNvPicPr>
+            <a:picLocks noChangeAspect="1"/>
+          </p:cNvPicPr>
+          <p:nvPr/>
+        </p:nvPicPr>
+        <p:blipFill>
+          <a:blip r:embed="rId4"/>
+          <a:stretch>
+            <a:fillRect/>
+          </a:stretch>
+        </p:blipFill>
+        <p:spPr>
+          <a:xfrm>
+            <a:off x="5943600" y="1097280"/>
+            <a:ext cx="5989320" cy="2767792"/>
+          </a:xfrm>
+          <a:prstGeom prst="rect">
+            <a:avLst/>
+          </a:prstGeom>
+        </p:spPr>
+      </p:pic>
+      <p:sp>
+        <p:nvSpPr>
+          <p:cNvPr id="17412" name="TextBox 17411"/>
+          <p:cNvSpPr txBox="1"/>
+          <p:nvPr/>
+        </p:nvSpPr>
+        <p:spPr>
+          <a:xfrm>
+            <a:off x="5943600" y="3840480"/>
+            <a:ext cx="5989320" cy="411480"/>
+          </a:xfrm>
+          <a:prstGeom prst="rect">
+            <a:avLst/>
+          </a:prstGeom>
+          <a:noFill/>
+        </p:spPr>
+        <p:txBody>
+          <a:bodyPr wrap="square">
+            <a:spAutoFit/>
+          </a:bodyPr>
+          <a:lstStyle/>
+          <a:p>
+            <a:pPr marL="0" indent="0">
+              <a:buNone/>
+            </a:pPr>
+            <a:r>
+              <a:rPr sz="900" b="0">
+                <a:solidFill>
+                  <a:srgbClr val="555555"/>
+                </a:solidFill>
+                <a:latin typeface="Arial"/>
+              </a:rPr>
+              <a:t>AUROC on unseen test data; 0.5 = chance. CICIoT2023 episodes are composed, so only detection is scored. *Mean over the six temporal datasets.</a:t>
+            </a:r>
+          </a:p>
+        </p:txBody>
+      </p:sp>
       <p:graphicFrame>
         <p:nvGraphicFramePr>
-          <p:cNvPr id="17411" name="Table 17410"/>
+          <p:cNvPr id="17413" name="Table 17412"/>
           <p:cNvGraphicFramePr>
             <a:graphicFrameLocks noGrp="1"/>
           </p:cNvGraphicFramePr>
           <p:nvPr/>
         </p:nvGraphicFramePr>
         <p:xfrm>
-          <a:off x="7543800" y="1325880"/>
-          <a:ext cx="4343399" cy="2468879"/>
+          <a:off x="411480" y="4343400"/>
+          <a:ext cx="11384280" cy="1755648"/>
         </p:xfrm>
         <a:graphic>
           <a:graphicData uri="http://schemas.openxmlformats.org/drawingml/2006/table">
@@ -7439,501 +7797,251 @@
                 <a:tableStyleId>{5C22544A-7EE6-4342-B048-85BDC9FD1C3A}</a:tableStyleId>
               </a:tblPr>
               <a:tblGrid>
-                <a:gridCol w="1874519"/>
-                <a:gridCol w="1234440"/>
-                <a:gridCol w="1234440"/>
+                <a:gridCol w="5440680"/>
+                <a:gridCol w="5943600"/>
               </a:tblGrid>
-              <a:tr h="274319">
+              <a:tr h="384048">
                 <a:tc>
                   <a:txBody>
                     <a:bodyPr/>
                     <a:lstStyle/>
                     <a:p>
-                      <a:pPr algn="l"/>
                       <a:r>
-                        <a:rPr sz="1100" b="1">
+                        <a:rPr sz="1400" b="1">
+                          <a:solidFill>
+                            <a:srgbClr val="FFFFFF"/>
+                          </a:solidFill>
                           <a:latin typeface="Arial"/>
                         </a:rPr>
-                        <a:t>Unseen test data</a:t>
+                        <a:t>Potential challenges and risks</a:t>
                       </a:r>
                     </a:p>
                   </a:txBody>
-                  <a:tcPr marT="27432" marB="27432"/>
+                  <a:tcPr anchor="ctr" marL="109728" marR="109728" marT="36576" marB="36576">
+                    <a:solidFill>
+                      <a:srgbClr val="1F4E9A"/>
+                    </a:solidFill>
+                  </a:tcPr>
                 </a:tc>
                 <a:tc>
                   <a:txBody>
                     <a:bodyPr/>
                     <a:lstStyle/>
                     <a:p>
-                      <a:pPr algn="ctr"/>
                       <a:r>
-                        <a:rPr sz="1100" b="1">
+                        <a:rPr sz="1400" b="1">
+                          <a:solidFill>
+                            <a:srgbClr val="FFFFFF"/>
+                          </a:solidFill>
                           <a:latin typeface="Arial"/>
                         </a:rPr>
-                        <a:t>Forecast</a:t>
+                        <a:t>Strategies for overcoming these challenges</a:t>
                       </a:r>
                     </a:p>
                   </a:txBody>
-                  <a:tcPr marT="27432" marB="27432"/>
+                  <a:tcPr anchor="ctr" marL="109728" marR="109728" marT="36576" marB="36576">
+                    <a:solidFill>
+                      <a:srgbClr val="1F4E9A"/>
+                    </a:solidFill>
+                  </a:tcPr>
+                </a:tc>
+              </a:tr>
+              <a:tr h="457200">
+                <a:tc>
+                  <a:txBody>
+                    <a:bodyPr/>
+                    <a:lstStyle/>
+                    <a:p>
+                      <a:r>
+                        <a:rPr sz="1250" b="1">
+                          <a:solidFill>
+                            <a:srgbClr val="202020"/>
+                          </a:solidFill>
+                          <a:latin typeface="Arial"/>
+                        </a:rPr>
+                        <a:t>Some attack types: </a:t>
+                      </a:r>
+                      <a:r>
+                        <a:rPr sz="1250" b="0">
+                          <a:solidFill>
+                            <a:srgbClr val="202020"/>
+                          </a:solidFill>
+                          <a:latin typeface="Arial"/>
+                        </a:rPr>
+                        <a:t>weak on LANL (authentication-based red team), behind the baseline on DARPA 1999</a:t>
+                      </a:r>
+                    </a:p>
+                  </a:txBody>
+                  <a:tcPr anchor="ctr" marL="109728" marR="109728" marT="36576" marB="36576">
+                    <a:solidFill>
+                      <a:srgbClr val="FFFFFF"/>
+                    </a:solidFill>
+                  </a:tcPr>
                 </a:tc>
                 <a:tc>
                   <a:txBody>
                     <a:bodyPr/>
                     <a:lstStyle/>
                     <a:p>
-                      <a:pPr algn="ctr"/>
                       <a:r>
-                        <a:rPr sz="1100" b="1">
+                        <a:rPr sz="1250" b="1">
+                          <a:solidFill>
+                            <a:srgbClr val="202020"/>
+                          </a:solidFill>
                           <a:latin typeface="Arial"/>
                         </a:rPr>
-                        <a:t>Detection</a:t>
+                        <a:t>Authentication-log and per-host modelling; </a:t>
+                      </a:r>
+                      <a:r>
+                        <a:rPr sz="1250" b="0">
+                          <a:solidFill>
+                            <a:srgbClr val="202020"/>
+                          </a:solidFill>
+                          <a:latin typeface="Arial"/>
+                        </a:rPr>
+                        <a:t>these limits are reported openly, not hidden</a:t>
                       </a:r>
                     </a:p>
                   </a:txBody>
-                  <a:tcPr marT="27432" marB="27432"/>
+                  <a:tcPr anchor="ctr" marL="109728" marR="109728" marT="36576" marB="36576">
+                    <a:solidFill>
+                      <a:srgbClr val="FFFFFF"/>
+                    </a:solidFill>
+                  </a:tcPr>
                 </a:tc>
               </a:tr>
-              <a:tr h="274319">
+              <a:tr h="457200">
                 <a:tc>
                   <a:txBody>
                     <a:bodyPr/>
                     <a:lstStyle/>
                     <a:p>
-                      <a:pPr algn="l"/>
                       <a:r>
-                        <a:rPr sz="1100" b="0">
+                        <a:rPr sz="1250" b="1">
+                          <a:solidFill>
+                            <a:srgbClr val="202020"/>
+                          </a:solidFill>
                           <a:latin typeface="Arial"/>
                         </a:rPr>
-                        <a:t>CTU-13</a:t>
+                        <a:t>New networks: </a:t>
+                      </a:r>
+                      <a:r>
+                        <a:rPr sz="1250" b="0">
+                          <a:solidFill>
+                            <a:srgbClr val="202020"/>
+                          </a:solidFill>
+                          <a:latin typeface="Arial"/>
+                        </a:rPr>
+                        <a:t>more false alarms where the model was not calibrated; behaviour drifts over time</a:t>
                       </a:r>
                     </a:p>
                   </a:txBody>
-                  <a:tcPr marT="27432" marB="27432"/>
+                  <a:tcPr anchor="ctr" marL="109728" marR="109728" marT="36576" marB="36576">
+                    <a:solidFill>
+                      <a:srgbClr val="EEF3FA"/>
+                    </a:solidFill>
+                  </a:tcPr>
                 </a:tc>
                 <a:tc>
                   <a:txBody>
                     <a:bodyPr/>
                     <a:lstStyle/>
                     <a:p>
-                      <a:pPr algn="ctr"/>
                       <a:r>
-                        <a:rPr sz="1100" b="0">
+                        <a:rPr sz="1250" b="1">
+                          <a:solidFill>
+                            <a:srgbClr val="202020"/>
+                          </a:solidFill>
                           <a:latin typeface="Arial"/>
                         </a:rPr>
-                        <a:t>0.83 / 0.60</a:t>
+                        <a:t>Per-network alert calibration </a:t>
+                      </a:r>
+                      <a:r>
+                        <a:rPr sz="1250" b="0">
+                          <a:solidFill>
+                            <a:srgbClr val="202020"/>
+                          </a:solidFill>
+                          <a:latin typeface="Arial"/>
+                        </a:rPr>
+                        <a:t>on the site's own traffic (built in); periodic retraining</a:t>
                       </a:r>
                     </a:p>
                   </a:txBody>
-                  <a:tcPr marT="27432" marB="27432"/>
+                  <a:tcPr anchor="ctr" marL="109728" marR="109728" marT="36576" marB="36576">
+                    <a:solidFill>
+                      <a:srgbClr val="EEF3FA"/>
+                    </a:solidFill>
+                  </a:tcPr>
+                </a:tc>
+              </a:tr>
+              <a:tr h="457200">
+                <a:tc>
+                  <a:txBody>
+                    <a:bodyPr/>
+                    <a:lstStyle/>
+                    <a:p>
+                      <a:r>
+                        <a:rPr sz="1250" b="1">
+                          <a:solidFill>
+                            <a:srgbClr val="202020"/>
+                          </a:solidFill>
+                          <a:latin typeface="Arial"/>
+                        </a:rPr>
+                        <a:t>Encryption: </a:t>
+                      </a:r>
+                      <a:r>
+                        <a:rPr sz="1250" b="0">
+                          <a:solidFill>
+                            <a:srgbClr val="202020"/>
+                          </a:solidFill>
+                          <a:latin typeface="Arial"/>
+                        </a:rPr>
+                        <a:t>payloads are hidden in encrypted traffic</a:t>
+                      </a:r>
+                    </a:p>
+                  </a:txBody>
+                  <a:tcPr anchor="ctr" marL="109728" marR="109728" marT="36576" marB="36576">
+                    <a:solidFill>
+                      <a:srgbClr val="FFFFFF"/>
+                    </a:solidFill>
+                  </a:tcPr>
                 </a:tc>
                 <a:tc>
                   <a:txBody>
                     <a:bodyPr/>
                     <a:lstStyle/>
                     <a:p>
-                      <a:pPr algn="ctr"/>
                       <a:r>
-                        <a:rPr sz="1100" b="0">
+                        <a:rPr sz="1250" b="1">
+                          <a:solidFill>
+                            <a:srgbClr val="202020"/>
+                          </a:solidFill>
                           <a:latin typeface="Arial"/>
                         </a:rPr>
-                        <a:t>0.89 / 0.74</a:t>
+                        <a:t>Flow-level features need no payload, </a:t>
+                      </a:r>
+                      <a:r>
+                        <a:rPr sz="1250" b="0">
+                          <a:solidFill>
+                            <a:srgbClr val="202020"/>
+                          </a:solidFill>
+                          <a:latin typeface="Arial"/>
+                        </a:rPr>
+                        <a:t>so the model works on encrypted and flow-only input</a:t>
                       </a:r>
                     </a:p>
                   </a:txBody>
-                  <a:tcPr marT="27432" marB="27432"/>
-                </a:tc>
-              </a:tr>
-              <a:tr h="274319">
-                <a:tc>
-                  <a:txBody>
-                    <a:bodyPr/>
-                    <a:lstStyle/>
-                    <a:p>
-                      <a:pPr algn="l"/>
-                      <a:r>
-                        <a:rPr sz="1100" b="0">
-                          <a:latin typeface="Arial"/>
-                        </a:rPr>
-                        <a:t>CIC-IDS2017</a:t>
-                      </a:r>
-                    </a:p>
-                  </a:txBody>
-                  <a:tcPr marT="27432" marB="27432"/>
-                </a:tc>
-                <a:tc>
-                  <a:txBody>
-                    <a:bodyPr/>
-                    <a:lstStyle/>
-                    <a:p>
-                      <a:pPr algn="ctr"/>
-                      <a:r>
-                        <a:rPr sz="1100" b="0">
-                          <a:latin typeface="Arial"/>
-                        </a:rPr>
-                        <a:t>0.56 / 0.56</a:t>
-                      </a:r>
-                    </a:p>
-                  </a:txBody>
-                  <a:tcPr marT="27432" marB="27432"/>
-                </a:tc>
-                <a:tc>
-                  <a:txBody>
-                    <a:bodyPr/>
-                    <a:lstStyle/>
-                    <a:p>
-                      <a:pPr algn="ctr"/>
-                      <a:r>
-                        <a:rPr sz="1100" b="0">
-                          <a:latin typeface="Arial"/>
-                        </a:rPr>
-                        <a:t>0.65 / 0.65</a:t>
-                      </a:r>
-                    </a:p>
-                  </a:txBody>
-                  <a:tcPr marT="27432" marB="27432"/>
-                </a:tc>
-              </a:tr>
-              <a:tr h="274319">
-                <a:tc>
-                  <a:txBody>
-                    <a:bodyPr/>
-                    <a:lstStyle/>
-                    <a:p>
-                      <a:pPr algn="l"/>
-                      <a:r>
-                        <a:rPr sz="1100" b="0">
-                          <a:latin typeface="Arial"/>
-                        </a:rPr>
-                        <a:t>CSE-CIC-IDS2018</a:t>
-                      </a:r>
-                    </a:p>
-                  </a:txBody>
-                  <a:tcPr marT="27432" marB="27432"/>
-                </a:tc>
-                <a:tc>
-                  <a:txBody>
-                    <a:bodyPr/>
-                    <a:lstStyle/>
-                    <a:p>
-                      <a:pPr algn="ctr"/>
-                      <a:r>
-                        <a:rPr sz="1100" b="0">
-                          <a:latin typeface="Arial"/>
-                        </a:rPr>
-                        <a:t>0.83 / 0.60</a:t>
-                      </a:r>
-                    </a:p>
-                  </a:txBody>
-                  <a:tcPr marT="27432" marB="27432"/>
-                </a:tc>
-                <a:tc>
-                  <a:txBody>
-                    <a:bodyPr/>
-                    <a:lstStyle/>
-                    <a:p>
-                      <a:pPr algn="ctr"/>
-                      <a:r>
-                        <a:rPr sz="1100" b="0">
-                          <a:latin typeface="Arial"/>
-                        </a:rPr>
-                        <a:t>0.83 / 0.62</a:t>
-                      </a:r>
-                    </a:p>
-                  </a:txBody>
-                  <a:tcPr marT="27432" marB="27432"/>
-                </a:tc>
-              </a:tr>
-              <a:tr h="274319">
-                <a:tc>
-                  <a:txBody>
-                    <a:bodyPr/>
-                    <a:lstStyle/>
-                    <a:p>
-                      <a:pPr algn="l"/>
-                      <a:r>
-                        <a:rPr sz="1100" b="0">
-                          <a:latin typeface="Arial"/>
-                        </a:rPr>
-                        <a:t>UNSW-NB15</a:t>
-                      </a:r>
-                    </a:p>
-                  </a:txBody>
-                  <a:tcPr marT="27432" marB="27432"/>
-                </a:tc>
-                <a:tc>
-                  <a:txBody>
-                    <a:bodyPr/>
-                    <a:lstStyle/>
-                    <a:p>
-                      <a:pPr algn="ctr"/>
-                      <a:r>
-                        <a:rPr sz="1100" b="0">
-                          <a:latin typeface="Arial"/>
-                        </a:rPr>
-                        <a:t>0.95 / 0.99</a:t>
-                      </a:r>
-                    </a:p>
-                  </a:txBody>
-                  <a:tcPr marT="27432" marB="27432"/>
-                </a:tc>
-                <a:tc>
-                  <a:txBody>
-                    <a:bodyPr/>
-                    <a:lstStyle/>
-                    <a:p>
-                      <a:pPr algn="ctr"/>
-                      <a:r>
-                        <a:rPr sz="1100" b="0">
-                          <a:latin typeface="Arial"/>
-                        </a:rPr>
-                        <a:t>1.00 / 0.95</a:t>
-                      </a:r>
-                    </a:p>
-                  </a:txBody>
-                  <a:tcPr marT="27432" marB="27432"/>
-                </a:tc>
-              </a:tr>
-              <a:tr h="274319">
-                <a:tc>
-                  <a:txBody>
-                    <a:bodyPr/>
-                    <a:lstStyle/>
-                    <a:p>
-                      <a:pPr algn="l"/>
-                      <a:r>
-                        <a:rPr sz="1100" b="0">
-                          <a:latin typeface="Arial"/>
-                        </a:rPr>
-                        <a:t>LANL cyber1</a:t>
-                      </a:r>
-                    </a:p>
-                  </a:txBody>
-                  <a:tcPr marT="27432" marB="27432"/>
-                </a:tc>
-                <a:tc>
-                  <a:txBody>
-                    <a:bodyPr/>
-                    <a:lstStyle/>
-                    <a:p>
-                      <a:pPr algn="ctr"/>
-                      <a:r>
-                        <a:rPr sz="1100" b="0">
-                          <a:latin typeface="Arial"/>
-                        </a:rPr>
-                        <a:t>0.37 / 0.56</a:t>
-                      </a:r>
-                    </a:p>
-                  </a:txBody>
-                  <a:tcPr marT="27432" marB="27432"/>
-                </a:tc>
-                <a:tc>
-                  <a:txBody>
-                    <a:bodyPr/>
-                    <a:lstStyle/>
-                    <a:p>
-                      <a:pPr algn="ctr"/>
-                      <a:r>
-                        <a:rPr sz="1100" b="0">
-                          <a:latin typeface="Arial"/>
-                        </a:rPr>
-                        <a:t>0.40 / 0.55</a:t>
-                      </a:r>
-                    </a:p>
-                  </a:txBody>
-                  <a:tcPr marT="27432" marB="27432"/>
-                </a:tc>
-              </a:tr>
-              <a:tr h="274319">
-                <a:tc>
-                  <a:txBody>
-                    <a:bodyPr/>
-                    <a:lstStyle/>
-                    <a:p>
-                      <a:pPr algn="l"/>
-                      <a:r>
-                        <a:rPr sz="1100" b="0">
-                          <a:latin typeface="Arial"/>
-                        </a:rPr>
-                        <a:t>DARPA 1999</a:t>
-                      </a:r>
-                    </a:p>
-                  </a:txBody>
-                  <a:tcPr marT="27432" marB="27432"/>
-                </a:tc>
-                <a:tc>
-                  <a:txBody>
-                    <a:bodyPr/>
-                    <a:lstStyle/>
-                    <a:p>
-                      <a:pPr algn="ctr"/>
-                      <a:r>
-                        <a:rPr sz="1100" b="0">
-                          <a:latin typeface="Arial"/>
-                        </a:rPr>
-                        <a:t>0.63 / 0.69</a:t>
-                      </a:r>
-                    </a:p>
-                  </a:txBody>
-                  <a:tcPr marT="27432" marB="27432"/>
-                </a:tc>
-                <a:tc>
-                  <a:txBody>
-                    <a:bodyPr/>
-                    <a:lstStyle/>
-                    <a:p>
-                      <a:pPr algn="ctr"/>
-                      <a:r>
-                        <a:rPr sz="1100" b="0">
-                          <a:latin typeface="Arial"/>
-                        </a:rPr>
-                        <a:t>0.69 / 0.81</a:t>
-                      </a:r>
-                    </a:p>
-                  </a:txBody>
-                  <a:tcPr marT="27432" marB="27432"/>
-                </a:tc>
-              </a:tr>
-              <a:tr h="274319">
-                <a:tc>
-                  <a:txBody>
-                    <a:bodyPr/>
-                    <a:lstStyle/>
-                    <a:p>
-                      <a:pPr algn="l"/>
-                      <a:r>
-                        <a:rPr sz="1100" b="0">
-                          <a:latin typeface="Arial"/>
-                        </a:rPr>
-                        <a:t>CICIoT2023</a:t>
-                      </a:r>
-                    </a:p>
-                  </a:txBody>
-                  <a:tcPr marT="27432" marB="27432"/>
-                </a:tc>
-                <a:tc>
-                  <a:txBody>
-                    <a:bodyPr/>
-                    <a:lstStyle/>
-                    <a:p>
-                      <a:pPr algn="ctr"/>
-                      <a:r>
-                        <a:rPr sz="1100" b="0">
-                          <a:latin typeface="Arial"/>
-                        </a:rPr>
-                        <a:t>n/a</a:t>
-                      </a:r>
-                    </a:p>
-                  </a:txBody>
-                  <a:tcPr marT="27432" marB="27432"/>
-                </a:tc>
-                <a:tc>
-                  <a:txBody>
-                    <a:bodyPr/>
-                    <a:lstStyle/>
-                    <a:p>
-                      <a:pPr algn="ctr"/>
-                      <a:r>
-                        <a:rPr sz="1100" b="0">
-                          <a:latin typeface="Arial"/>
-                        </a:rPr>
-                        <a:t>0.99 / 0.76</a:t>
-                      </a:r>
-                    </a:p>
-                  </a:txBody>
-                  <a:tcPr marT="27432" marB="27432"/>
-                </a:tc>
-              </a:tr>
-              <a:tr h="274327">
-                <a:tc>
-                  <a:txBody>
-                    <a:bodyPr/>
-                    <a:lstStyle/>
-                    <a:p>
-                      <a:pPr algn="l"/>
-                      <a:r>
-                        <a:rPr sz="1100" b="1">
-                          <a:latin typeface="Arial"/>
-                        </a:rPr>
-                        <a:t>Macro average</a:t>
-                      </a:r>
-                    </a:p>
-                  </a:txBody>
-                  <a:tcPr marT="27432" marB="27432"/>
-                </a:tc>
-                <a:tc>
-                  <a:txBody>
-                    <a:bodyPr/>
-                    <a:lstStyle/>
-                    <a:p>
-                      <a:pPr algn="ctr"/>
-                      <a:r>
-                        <a:rPr sz="1100" b="1">
-                          <a:latin typeface="Arial"/>
-                        </a:rPr>
-                        <a:t>0.70 / 0.67</a:t>
-                      </a:r>
-                    </a:p>
-                  </a:txBody>
-                  <a:tcPr marT="27432" marB="27432"/>
-                </a:tc>
-                <a:tc>
-                  <a:txBody>
-                    <a:bodyPr/>
-                    <a:lstStyle/>
-                    <a:p>
-                      <a:pPr algn="ctr"/>
-                      <a:r>
-                        <a:rPr sz="1100" b="1">
-                          <a:latin typeface="Arial"/>
-                        </a:rPr>
-                        <a:t>0.74 / 0.72</a:t>
-                      </a:r>
-                    </a:p>
-                  </a:txBody>
-                  <a:tcPr marT="27432" marB="27432"/>
+                  <a:tcPr anchor="ctr" marL="109728" marR="109728" marT="36576" marB="36576">
+                    <a:solidFill>
+                      <a:srgbClr val="FFFFFF"/>
+                    </a:solidFill>
+                  </a:tcPr>
                 </a:tc>
               </a:tr>
             </a:tbl>
           </a:graphicData>
         </a:graphic>
       </p:graphicFrame>
-      <p:sp>
-        <p:nvSpPr>
-          <p:cNvPr id="17412" name="TextBox 17411"/>
-          <p:cNvSpPr txBox="1"/>
-          <p:nvPr/>
-        </p:nvSpPr>
-        <p:spPr>
-          <a:xfrm>
-            <a:off x="7543800" y="3840479"/>
-            <a:ext cx="4343400" cy="457200"/>
-          </a:xfrm>
-          <a:prstGeom prst="rect">
-            <a:avLst/>
-          </a:prstGeom>
-          <a:noFill/>
-        </p:spPr>
-        <p:txBody>
-          <a:bodyPr wrap="square">
-            <a:spAutoFit/>
-          </a:bodyPr>
-          <a:lstStyle/>
-          <a:p>
-            <a:pPr marL="228600" indent="-228600">
-              <a:buNone/>
-            </a:pPr>
-            <a:r>
-              <a:rPr sz="950" b="0">
-                <a:solidFill>
-                  <a:srgbClr val="555555"/>
-                </a:solidFill>
-                <a:latin typeface="Arial"/>
-              </a:rPr>
-              <a:t>AUROC, world model / logistic-regression baseline on the same features. CICIoT2023 episodes are composed, so only detection is scored.</a:t>
-            </a:r>
-          </a:p>
-        </p:txBody>
-      </p:sp>
     </p:spTree>
     <p:extLst>
       <p:ext uri="{BB962C8B-B14F-4D97-AF65-F5344CB8AC3E}">
@@ -8081,7 +8189,7 @@
         <p:spPr bwMode="auto">
           <a:xfrm>
             <a:off x="411480" y="1143000"/>
-            <a:ext cx="6309360" cy="5120640"/>
+            <a:ext cx="5852160" cy="2240280"/>
           </a:xfrm>
           <a:prstGeom prst="rect">
             <a:avLst/>
@@ -8118,7 +8226,7 @@
               <a:defRPr/>
             </a:pPr>
             <a:r>
-              <a:rPr sz="1500" b="1">
+              <a:rPr sz="1550" b="1">
                 <a:solidFill>
                   <a:srgbClr val="1F4E9A"/>
                 </a:solidFill>
@@ -8130,181 +8238,82 @@
           <a:p>
             <a:pPr marL="457200" indent="-228600">
               <a:spcBef>
-                <a:spcPts val="200"/>
+                <a:spcPts val="300"/>
               </a:spcBef>
               <a:buFont typeface="Arial"/>
               <a:buChar char="•"/>
             </a:pPr>
             <a:r>
+              <a:rPr sz="1350" b="1">
+                <a:solidFill>
+                  <a:srgbClr val="202020"/>
+                </a:solidFill>
+                <a:latin typeface="Arial"/>
+              </a:rPr>
+              <a:t>Early warning </a:t>
+            </a:r>
+            <a:r>
               <a:rPr sz="1350" b="0">
                 <a:solidFill>
                   <a:srgbClr val="202020"/>
                 </a:solidFill>
                 <a:latin typeface="Arial"/>
               </a:rPr>
-              <a:t>NTRO, NCIIPC, CERT-In and critical-infrastructure SOCs get a warning before an attack completes, with time to isolate hosts</a:t>
+              <a:t>for NTRO, NCIIPC, CERT-In and critical-infrastructure SOCs, with time to isolate hosts</a:t>
             </a:r>
           </a:p>
           <a:p>
             <a:pPr marL="457200" indent="-228600">
               <a:spcBef>
-                <a:spcPts val="200"/>
+                <a:spcPts val="300"/>
               </a:spcBef>
               <a:buFont typeface="Arial"/>
               <a:buChar char="•"/>
             </a:pPr>
             <a:r>
+              <a:rPr sz="1350" b="1">
+                <a:solidFill>
+                  <a:srgbClr val="202020"/>
+                </a:solidFill>
+                <a:latin typeface="Arial"/>
+              </a:rPr>
+              <a:t>Faster triage: </a:t>
+            </a:r>
+            <a:r>
               <a:rPr sz="1350" b="0">
                 <a:solidFill>
                   <a:srgbClr val="202020"/>
                 </a:solidFill>
                 <a:latin typeface="Arial"/>
               </a:rPr>
-              <a:t>Every alert arrives with its reasons and the responsible hosts and flows, so triage is faster</a:t>
+              <a:t>every alert comes with its reasons and the hosts and flows behind it</a:t>
             </a:r>
           </a:p>
           <a:p>
             <a:pPr marL="457200" indent="-228600">
               <a:spcBef>
-                <a:spcPts val="200"/>
+                <a:spcPts val="300"/>
               </a:spcBef>
               <a:buFont typeface="Arial"/>
               <a:buChar char="•"/>
             </a:pPr>
             <a:r>
+              <a:rPr sz="1350" b="1">
+                <a:solidFill>
+                  <a:srgbClr val="202020"/>
+                </a:solidFill>
+                <a:latin typeface="Arial"/>
+              </a:rPr>
+              <a:t>Deployable anywhere: </a:t>
+            </a:r>
+            <a:r>
               <a:rPr sz="1350" b="0">
                 <a:solidFill>
                   <a:srgbClr val="202020"/>
                 </a:solidFill>
                 <a:latin typeface="Arial"/>
               </a:rPr>
-              <a:t>Runs air-gapped on ordinary hardware, including classified and low-resource networks</a:t>
-            </a:r>
-          </a:p>
-          <a:p>
-            <a:pPr marL="228600" indent="-228600">
-              <a:spcBef>
-                <a:spcPts val="800"/>
-              </a:spcBef>
-              <a:buFont typeface="Wingdings"/>
-              <a:buChar char="v"/>
-            </a:pPr>
-            <a:r>
-              <a:rPr sz="1500" b="1">
-                <a:solidFill>
-                  <a:srgbClr val="1F4E9A"/>
-                </a:solidFill>
-                <a:latin typeface="Arial"/>
-              </a:rPr>
-              <a:t>Benefits of the solution (social, economic, environmental, etc.)</a:t>
-            </a:r>
-          </a:p>
-          <a:p>
-            <a:pPr marL="457200" indent="-228600">
-              <a:spcBef>
-                <a:spcPts val="200"/>
-              </a:spcBef>
-              <a:buFont typeface="Arial"/>
-              <a:buChar char="•"/>
-            </a:pPr>
-            <a:r>
-              <a:rPr sz="1350" b="1">
-                <a:solidFill>
-                  <a:srgbClr val="202020"/>
-                </a:solidFill>
-                <a:latin typeface="Arial"/>
-              </a:rPr>
-              <a:t>Security: </a:t>
-            </a:r>
-            <a:r>
-              <a:rPr sz="1350" b="0">
-                <a:solidFill>
-                  <a:srgbClr val="202020"/>
-                </a:solidFill>
-                <a:latin typeface="Arial"/>
-              </a:rPr>
-              <a:t>earlier containment of botnets, DDoS and lateral movement on national infrastructure</a:t>
-            </a:r>
-          </a:p>
-          <a:p>
-            <a:pPr marL="457200" indent="-228600">
-              <a:spcBef>
-                <a:spcPts val="200"/>
-              </a:spcBef>
-              <a:buFont typeface="Arial"/>
-              <a:buChar char="•"/>
-            </a:pPr>
-            <a:r>
-              <a:rPr sz="1350" b="1">
-                <a:solidFill>
-                  <a:srgbClr val="202020"/>
-                </a:solidFill>
-                <a:latin typeface="Arial"/>
-              </a:rPr>
-              <a:t>Social: </a:t>
-            </a:r>
-            <a:r>
-              <a:rPr sz="1350" b="0">
-                <a:solidFill>
-                  <a:srgbClr val="202020"/>
-                </a:solidFill>
-                <a:latin typeface="Arial"/>
-              </a:rPr>
-              <a:t>protects power, banking, health and e-governance services citizens rely on</a:t>
-            </a:r>
-          </a:p>
-          <a:p>
-            <a:pPr marL="457200" indent="-228600">
-              <a:spcBef>
-                <a:spcPts val="200"/>
-              </a:spcBef>
-              <a:buFont typeface="Arial"/>
-              <a:buChar char="•"/>
-            </a:pPr>
-            <a:r>
-              <a:rPr sz="1350" b="1">
-                <a:solidFill>
-                  <a:srgbClr val="202020"/>
-                </a:solidFill>
-                <a:latin typeface="Arial"/>
-              </a:rPr>
-              <a:t>Economic: </a:t>
-            </a:r>
-            <a:r>
-              <a:rPr sz="1350" b="0">
-                <a:solidFill>
-                  <a:srgbClr val="202020"/>
-                </a:solidFill>
-                <a:latin typeface="Arial"/>
-              </a:rPr>
-              <a:t>open source, no licence or cloud cost; one CPU core covers a network segment</a:t>
-            </a:r>
-          </a:p>
-          <a:p>
-            <a:pPr marL="457200" indent="-228600">
-              <a:spcBef>
-                <a:spcPts val="200"/>
-              </a:spcBef>
-              <a:buFont typeface="Arial"/>
-              <a:buChar char="•"/>
-            </a:pPr>
-            <a:r>
-              <a:rPr sz="1350" b="1">
-                <a:solidFill>
-                  <a:srgbClr val="202020"/>
-                </a:solidFill>
-                <a:latin typeface="Arial"/>
-              </a:rPr>
-              <a:t>Sovereignty: </a:t>
-            </a:r>
-            <a:r>
-              <a:rPr sz="1350" b="0">
-                <a:solidFill>
-                  <a:srgbClr val="202020"/>
-                </a:solidFill>
-                <a:latin typeface="Arial"/>
-              </a:rPr>
-              <a:t>indigenous, auditable AI; verified weights; no data leaves the network</a:t>
+              <a:t>air-gapped, on ordinary hardware, including classified networks</a:t>
             </a:r>
           </a:p>
         </p:txBody>
@@ -8544,9 +8553,343 @@
           </a:prstGeom>
         </p:spPr>
       </p:pic>
+      <p:sp>
+        <p:nvSpPr>
+          <p:cNvPr id="17411" name="TextBox 17410"/>
+          <p:cNvSpPr txBox="1"/>
+          <p:nvPr/>
+        </p:nvSpPr>
+        <p:spPr>
+          <a:xfrm>
+            <a:off x="411480" y="3017520"/>
+            <a:ext cx="6080760" cy="365760"/>
+          </a:xfrm>
+          <a:prstGeom prst="rect">
+            <a:avLst/>
+          </a:prstGeom>
+          <a:noFill/>
+        </p:spPr>
+        <p:txBody>
+          <a:bodyPr wrap="square">
+            <a:spAutoFit/>
+          </a:bodyPr>
+          <a:lstStyle/>
+          <a:p>
+            <a:pPr marL="228600" indent="-228600">
+              <a:buFont typeface="Wingdings"/>
+              <a:buChar char="v"/>
+            </a:pPr>
+            <a:r>
+              <a:rPr sz="1450" b="1">
+                <a:solidFill>
+                  <a:srgbClr val="1F4E9A"/>
+                </a:solidFill>
+                <a:latin typeface="Arial"/>
+              </a:rPr>
+              <a:t>Benefits of the solution (social, economic, environmental, etc.)</a:t>
+            </a:r>
+          </a:p>
+        </p:txBody>
+      </p:sp>
+      <p:sp>
+        <p:nvSpPr>
+          <p:cNvPr id="17412" name="Rounded Rectangle 17411"/>
+          <p:cNvSpPr/>
+          <p:nvPr/>
+        </p:nvSpPr>
+        <p:spPr>
+          <a:xfrm>
+            <a:off x="502920" y="3520440"/>
+            <a:ext cx="2862072" cy="1207008"/>
+          </a:xfrm>
+          <a:prstGeom prst="roundRect">
+            <a:avLst>
+              <a:gd name="adj" fmla="val 7000"/>
+            </a:avLst>
+          </a:prstGeom>
+          <a:solidFill>
+            <a:srgbClr val="EEF3FA"/>
+          </a:solidFill>
+          <a:ln>
+            <a:noFill/>
+          </a:ln>
+          <a:effectLst/>
+        </p:spPr>
+        <p:style>
+          <a:lnRef idx="1">
+            <a:schemeClr val="accent1"/>
+          </a:lnRef>
+          <a:fillRef idx="3">
+            <a:schemeClr val="accent1"/>
+          </a:fillRef>
+          <a:effectRef idx="2">
+            <a:schemeClr val="accent1"/>
+          </a:effectRef>
+          <a:fontRef idx="minor">
+            <a:schemeClr val="lt1"/>
+          </a:fontRef>
+        </p:style>
+        <p:txBody>
+          <a:bodyPr rtlCol="0" anchor="t" wrap="square" lIns="128016" rIns="128016" tIns="64008" bIns="64008"/>
+          <a:lstStyle/>
+          <a:p>
+            <a:pPr algn="l" marL="0" indent="0">
+              <a:buNone/>
+            </a:pPr>
+            <a:r>
+              <a:rPr sz="1350" b="1">
+                <a:solidFill>
+                  <a:srgbClr val="1F4E9A"/>
+                </a:solidFill>
+                <a:latin typeface="Arial"/>
+              </a:rPr>
+              <a:t>Security</a:t>
+            </a:r>
+          </a:p>
+          <a:p>
+            <a:pPr marL="0" indent="0" algn="l">
+              <a:spcBef>
+                <a:spcPts val="300"/>
+              </a:spcBef>
+              <a:buNone/>
+            </a:pPr>
+            <a:r>
+              <a:rPr sz="1150" b="0">
+                <a:solidFill>
+                  <a:srgbClr val="202020"/>
+                </a:solidFill>
+                <a:latin typeface="Arial"/>
+              </a:rPr>
+              <a:t>Earlier containment of botnets, DDoS and lateral movement on national infrastructure</a:t>
+            </a:r>
+          </a:p>
+        </p:txBody>
+      </p:sp>
+      <p:sp>
+        <p:nvSpPr>
+          <p:cNvPr id="17413" name="Rounded Rectangle 17412"/>
+          <p:cNvSpPr/>
+          <p:nvPr/>
+        </p:nvSpPr>
+        <p:spPr>
+          <a:xfrm>
+            <a:off x="3493008" y="3520440"/>
+            <a:ext cx="2862072" cy="1207008"/>
+          </a:xfrm>
+          <a:prstGeom prst="roundRect">
+            <a:avLst>
+              <a:gd name="adj" fmla="val 7000"/>
+            </a:avLst>
+          </a:prstGeom>
+          <a:solidFill>
+            <a:srgbClr val="EEF3FA"/>
+          </a:solidFill>
+          <a:ln>
+            <a:noFill/>
+          </a:ln>
+          <a:effectLst/>
+        </p:spPr>
+        <p:style>
+          <a:lnRef idx="1">
+            <a:schemeClr val="accent1"/>
+          </a:lnRef>
+          <a:fillRef idx="3">
+            <a:schemeClr val="accent1"/>
+          </a:fillRef>
+          <a:effectRef idx="2">
+            <a:schemeClr val="accent1"/>
+          </a:effectRef>
+          <a:fontRef idx="minor">
+            <a:schemeClr val="lt1"/>
+          </a:fontRef>
+        </p:style>
+        <p:txBody>
+          <a:bodyPr rtlCol="0" anchor="t" wrap="square" lIns="128016" rIns="128016" tIns="64008" bIns="64008"/>
+          <a:lstStyle/>
+          <a:p>
+            <a:pPr algn="l" marL="0" indent="0">
+              <a:buNone/>
+            </a:pPr>
+            <a:r>
+              <a:rPr sz="1350" b="1">
+                <a:solidFill>
+                  <a:srgbClr val="1F4E9A"/>
+                </a:solidFill>
+                <a:latin typeface="Arial"/>
+              </a:rPr>
+              <a:t>Social</a:t>
+            </a:r>
+          </a:p>
+          <a:p>
+            <a:pPr marL="0" indent="0" algn="l">
+              <a:spcBef>
+                <a:spcPts val="300"/>
+              </a:spcBef>
+              <a:buNone/>
+            </a:pPr>
+            <a:r>
+              <a:rPr sz="1150" b="0">
+                <a:solidFill>
+                  <a:srgbClr val="202020"/>
+                </a:solidFill>
+                <a:latin typeface="Arial"/>
+              </a:rPr>
+              <a:t>Protects power, banking, health and e-governance services that citizens use</a:t>
+            </a:r>
+          </a:p>
+        </p:txBody>
+      </p:sp>
+      <p:sp>
+        <p:nvSpPr>
+          <p:cNvPr id="17414" name="Rounded Rectangle 17413"/>
+          <p:cNvSpPr/>
+          <p:nvPr/>
+        </p:nvSpPr>
+        <p:spPr>
+          <a:xfrm>
+            <a:off x="502920" y="4855464"/>
+            <a:ext cx="2862072" cy="1207008"/>
+          </a:xfrm>
+          <a:prstGeom prst="roundRect">
+            <a:avLst>
+              <a:gd name="adj" fmla="val 7000"/>
+            </a:avLst>
+          </a:prstGeom>
+          <a:solidFill>
+            <a:srgbClr val="EEF3FA"/>
+          </a:solidFill>
+          <a:ln>
+            <a:noFill/>
+          </a:ln>
+          <a:effectLst/>
+        </p:spPr>
+        <p:style>
+          <a:lnRef idx="1">
+            <a:schemeClr val="accent1"/>
+          </a:lnRef>
+          <a:fillRef idx="3">
+            <a:schemeClr val="accent1"/>
+          </a:fillRef>
+          <a:effectRef idx="2">
+            <a:schemeClr val="accent1"/>
+          </a:effectRef>
+          <a:fontRef idx="minor">
+            <a:schemeClr val="lt1"/>
+          </a:fontRef>
+        </p:style>
+        <p:txBody>
+          <a:bodyPr rtlCol="0" anchor="t" wrap="square" lIns="128016" rIns="128016" tIns="64008" bIns="64008"/>
+          <a:lstStyle/>
+          <a:p>
+            <a:pPr algn="l" marL="0" indent="0">
+              <a:buNone/>
+            </a:pPr>
+            <a:r>
+              <a:rPr sz="1350" b="1">
+                <a:solidFill>
+                  <a:srgbClr val="1F4E9A"/>
+                </a:solidFill>
+                <a:latin typeface="Arial"/>
+              </a:rPr>
+              <a:t>Economic</a:t>
+            </a:r>
+          </a:p>
+          <a:p>
+            <a:pPr marL="0" indent="0" algn="l">
+              <a:spcBef>
+                <a:spcPts val="300"/>
+              </a:spcBef>
+              <a:buNone/>
+            </a:pPr>
+            <a:r>
+              <a:rPr sz="1150" b="0">
+                <a:solidFill>
+                  <a:srgbClr val="202020"/>
+                </a:solidFill>
+                <a:latin typeface="Arial"/>
+              </a:rPr>
+              <a:t>Open source: no licence or cloud cost; one CPU core per network segment</a:t>
+            </a:r>
+          </a:p>
+        </p:txBody>
+      </p:sp>
+      <p:sp>
+        <p:nvSpPr>
+          <p:cNvPr id="17415" name="Rounded Rectangle 17414"/>
+          <p:cNvSpPr/>
+          <p:nvPr/>
+        </p:nvSpPr>
+        <p:spPr>
+          <a:xfrm>
+            <a:off x="3493008" y="4855464"/>
+            <a:ext cx="2862072" cy="1207008"/>
+          </a:xfrm>
+          <a:prstGeom prst="roundRect">
+            <a:avLst>
+              <a:gd name="adj" fmla="val 7000"/>
+            </a:avLst>
+          </a:prstGeom>
+          <a:solidFill>
+            <a:srgbClr val="EEF3FA"/>
+          </a:solidFill>
+          <a:ln>
+            <a:noFill/>
+          </a:ln>
+          <a:effectLst/>
+        </p:spPr>
+        <p:style>
+          <a:lnRef idx="1">
+            <a:schemeClr val="accent1"/>
+          </a:lnRef>
+          <a:fillRef idx="3">
+            <a:schemeClr val="accent1"/>
+          </a:fillRef>
+          <a:effectRef idx="2">
+            <a:schemeClr val="accent1"/>
+          </a:effectRef>
+          <a:fontRef idx="minor">
+            <a:schemeClr val="lt1"/>
+          </a:fontRef>
+        </p:style>
+        <p:txBody>
+          <a:bodyPr rtlCol="0" anchor="t" wrap="square" lIns="128016" rIns="128016" tIns="64008" bIns="64008"/>
+          <a:lstStyle/>
+          <a:p>
+            <a:pPr algn="l" marL="0" indent="0">
+              <a:buNone/>
+            </a:pPr>
+            <a:r>
+              <a:rPr sz="1350" b="1">
+                <a:solidFill>
+                  <a:srgbClr val="1F4E9A"/>
+                </a:solidFill>
+                <a:latin typeface="Arial"/>
+              </a:rPr>
+              <a:t>Sovereignty</a:t>
+            </a:r>
+          </a:p>
+          <a:p>
+            <a:pPr marL="0" indent="0" algn="l">
+              <a:spcBef>
+                <a:spcPts val="300"/>
+              </a:spcBef>
+              <a:buNone/>
+            </a:pPr>
+            <a:r>
+              <a:rPr sz="1150" b="0">
+                <a:solidFill>
+                  <a:srgbClr val="202020"/>
+                </a:solidFill>
+                <a:latin typeface="Arial"/>
+              </a:rPr>
+              <a:t>Indigenous, auditable AI; verified weights; no data leaves the network</a:t>
+            </a:r>
+          </a:p>
+        </p:txBody>
+      </p:sp>
       <p:pic>
         <p:nvPicPr>
-          <p:cNvPr id="17411" name="Picture 17410" descr="dashboard_light.png"/>
+          <p:cNvPr id="17416" name="Picture 17415" descr="dashboard_light.png"/>
           <p:cNvPicPr>
             <a:picLocks noChangeAspect="1"/>
           </p:cNvPicPr>
@@ -8560,8 +8903,76 @@
         </p:blipFill>
         <p:spPr>
           <a:xfrm>
-            <a:off x="6903720" y="1417320"/>
-            <a:ext cx="5074920" cy="2734818"/>
+            <a:off x="6537960" y="1234440"/>
+            <a:ext cx="5349240" cy="2882646"/>
+          </a:xfrm>
+          <a:prstGeom prst="rect">
+            <a:avLst/>
+          </a:prstGeom>
+          <a:ln w="9525">
+            <a:solidFill>
+              <a:srgbClr val="C9D3E3"/>
+            </a:solidFill>
+          </a:ln>
+        </p:spPr>
+      </p:pic>
+      <p:sp>
+        <p:nvSpPr>
+          <p:cNvPr id="17417" name="TextBox 17416"/>
+          <p:cNvSpPr txBox="1"/>
+          <p:nvPr/>
+        </p:nvSpPr>
+        <p:spPr>
+          <a:xfrm>
+            <a:off x="6537960" y="4162805"/>
+            <a:ext cx="5349240" cy="548640"/>
+          </a:xfrm>
+          <a:prstGeom prst="rect">
+            <a:avLst/>
+          </a:prstGeom>
+          <a:noFill/>
+        </p:spPr>
+        <p:txBody>
+          <a:bodyPr wrap="square">
+            <a:spAutoFit/>
+          </a:bodyPr>
+          <a:lstStyle/>
+          <a:p>
+            <a:pPr marL="0" indent="0">
+              <a:buNone/>
+            </a:pPr>
+            <a:r>
+              <a:rPr sz="1000" b="0">
+                <a:solidFill>
+                  <a:srgbClr val="555555"/>
+                </a:solidFill>
+                <a:latin typeface="Arial"/>
+              </a:rPr>
+              <a:t>A real CIC-IDS2017 day never seen in training: risk stays low for six minutes, then goes critical as the DDoS starts; the baseline (dashed) raises false spikes.</a:t>
+            </a:r>
+          </a:p>
+        </p:txBody>
+      </p:sp>
+      <p:pic>
+        <p:nvPicPr>
+          <p:cNvPr id="17418" name="Picture 17417" descr="qr_video.png">
+            <a:hlinkClick r:id="rId6"/>
+          </p:cNvPr>
+          <p:cNvPicPr>
+            <a:picLocks noChangeAspect="1"/>
+          </p:cNvPicPr>
+          <p:nvPr/>
+        </p:nvPicPr>
+        <p:blipFill>
+          <a:blip r:embed="rId5"/>
+          <a:stretch>
+            <a:fillRect/>
+          </a:stretch>
+        </p:blipFill>
+        <p:spPr>
+          <a:xfrm>
+            <a:off x="6537960" y="4754880"/>
+            <a:ext cx="1325880" cy="1325880"/>
           </a:xfrm>
           <a:prstGeom prst="rect">
             <a:avLst/>
@@ -8570,14 +8981,14 @@
       </p:pic>
       <p:sp>
         <p:nvSpPr>
-          <p:cNvPr id="17412" name="TextBox 17411"/>
+          <p:cNvPr id="17419" name="TextBox 17418"/>
           <p:cNvSpPr txBox="1"/>
           <p:nvPr/>
         </p:nvSpPr>
         <p:spPr>
           <a:xfrm>
-            <a:off x="6903720" y="4206240"/>
-            <a:ext cx="5074920" cy="548640"/>
+            <a:off x="8001000" y="4983480"/>
+            <a:ext cx="3886200" cy="1005840"/>
           </a:xfrm>
           <a:prstGeom prst="rect">
             <a:avLst/>
@@ -8590,17 +9001,52 @@
           </a:bodyPr>
           <a:lstStyle/>
           <a:p>
-            <a:pPr marL="228600" indent="-228600">
+            <a:pPr marL="0" indent="0">
               <a:buNone/>
             </a:pPr>
             <a:r>
+              <a:rPr sz="1500" b="1">
+                <a:solidFill>
+                  <a:srgbClr val="1F4E9A"/>
+                </a:solidFill>
+                <a:latin typeface="Arial"/>
+              </a:rPr>
+              <a:t>Watch the 2-minute demo</a:t>
+            </a:r>
+          </a:p>
+          <a:p>
+            <a:pPr marL="0" indent="0">
+              <a:spcBef>
+                <a:spcPts val="200"/>
+              </a:spcBef>
+              <a:buNone/>
+            </a:pPr>
+            <a:r>
+              <a:rPr sz="1250" b="0">
+                <a:solidFill>
+                  <a:srgbClr val="202020"/>
+                </a:solidFill>
+                <a:latin typeface="Arial"/>
+                <a:hlinkClick r:id="rId6"/>
+              </a:rPr>
+              <a:t>https://youtu.be/pPTe-d_TByU</a:t>
+            </a:r>
+          </a:p>
+          <a:p>
+            <a:pPr marL="0" indent="0">
+              <a:spcBef>
+                <a:spcPts val="200"/>
+              </a:spcBef>
+              <a:buNone/>
+            </a:pPr>
+            <a:r>
               <a:rPr sz="1000" b="0">
                 <a:solidFill>
                   <a:srgbClr val="555555"/>
                 </a:solidFill>
                 <a:latin typeface="Arial"/>
               </a:rPr>
-              <a:t>Working prototype: a real CIC-IDS2017 day never seen in training. Risk stays low for six minutes, then goes critical as the DDoS starts; the baseline (dashed) raises false spikes.</a:t>
+              <a:t>Scan the code or click the link</a:t>
             </a:r>
           </a:p>
         </p:txBody>
@@ -8752,7 +9198,7 @@
         <p:spPr bwMode="auto">
           <a:xfrm>
             <a:off x="411480" y="1143000"/>
-            <a:ext cx="11338560" cy="5120640"/>
+            <a:ext cx="8001000" cy="5120640"/>
           </a:xfrm>
           <a:prstGeom prst="rect">
             <a:avLst/>
@@ -8813,213 +9259,266 @@
             </a:endParaRPr>
           </a:p>
           <a:p>
+            <a:pPr marL="0" indent="0">
+              <a:spcBef>
+                <a:spcPts val="900"/>
+              </a:spcBef>
+              <a:buNone/>
+            </a:pPr>
+            <a:r>
+              <a:rPr sz="1450" b="1">
+                <a:solidFill>
+                  <a:srgbClr val="1F4E9A"/>
+                </a:solidFill>
+                <a:latin typeface="Arial"/>
+              </a:rPr>
+              <a:t>Research</a:t>
+            </a:r>
+          </a:p>
+          <a:p>
             <a:pPr marL="457200" indent="-228600">
               <a:spcBef>
-                <a:spcPts val="200"/>
+                <a:spcPts val="300"/>
               </a:spcBef>
               <a:buFont typeface="Arial"/>
               <a:buChar char="•"/>
             </a:pPr>
             <a:r>
-              <a:rPr sz="1550" b="1">
+              <a:rPr sz="1300" b="1">
                 <a:solidFill>
                   <a:srgbClr val="202020"/>
                 </a:solidFill>
                 <a:latin typeface="Arial"/>
               </a:rPr>
-              <a:t>Source code, weights, benchmark: </a:t>
-            </a:r>
-            <a:r>
-              <a:rPr sz="1550" b="0">
+              <a:t>World models: </a:t>
+            </a:r>
+            <a:r>
+              <a:rPr sz="1300" b="0">
                 <a:solidFill>
                   <a:srgbClr val="202020"/>
                 </a:solidFill>
                 <a:latin typeface="Arial"/>
               </a:rPr>
-              <a:t>https://github.com/NAMAN-THAKUR-1944/SIH2026-SIH26153-VIGHNAX</a:t>
+              <a:t>Ha &amp; Schmidhuber, World Models (2018); Hafner et al., recurrent state-space model, Learning Latent Dynamics for Planning from Pixels, ICML 2019</a:t>
             </a:r>
           </a:p>
           <a:p>
             <a:pPr marL="457200" indent="-228600">
               <a:spcBef>
-                <a:spcPts val="200"/>
+                <a:spcPts val="300"/>
               </a:spcBef>
               <a:buFont typeface="Arial"/>
               <a:buChar char="•"/>
             </a:pPr>
             <a:r>
-              <a:rPr sz="1550" b="1">
+              <a:rPr sz="1300" b="1">
                 <a:solidFill>
                   <a:srgbClr val="202020"/>
                 </a:solidFill>
                 <a:latin typeface="Arial"/>
               </a:rPr>
-              <a:t>World models: </a:t>
-            </a:r>
-            <a:r>
-              <a:rPr sz="1550" b="0">
+              <a:t>Explainability: </a:t>
+            </a:r>
+            <a:r>
+              <a:rPr sz="1300" b="0">
                 <a:solidFill>
                   <a:srgbClr val="202020"/>
                 </a:solidFill>
                 <a:latin typeface="Arial"/>
               </a:rPr>
-              <a:t>Ha &amp; Schmidhuber, World Models (2018); Hafner et al., Learning Latent Dynamics for Planning from Pixels, ICML 2019 (recurrent state-space model)</a:t>
+              <a:t>Sundararajan, Taly &amp; Yan, Axiomatic Attribution for Deep Networks (Integrated Gradients), ICML 2017</a:t>
             </a:r>
           </a:p>
           <a:p>
             <a:pPr marL="457200" indent="-228600">
               <a:spcBef>
-                <a:spcPts val="200"/>
+                <a:spcPts val="300"/>
               </a:spcBef>
               <a:buFont typeface="Arial"/>
               <a:buChar char="•"/>
             </a:pPr>
             <a:r>
-              <a:rPr sz="1550" b="1">
+              <a:rPr sz="1300" b="1">
                 <a:solidFill>
                   <a:srgbClr val="202020"/>
                 </a:solidFill>
                 <a:latin typeface="Arial"/>
               </a:rPr>
-              <a:t>Explainability: </a:t>
-            </a:r>
-            <a:r>
-              <a:rPr sz="1550" b="0">
+              <a:t>Attack stages and guidance: </a:t>
+            </a:r>
+            <a:r>
+              <a:rPr sz="1300" b="0">
                 <a:solidFill>
                   <a:srgbClr val="202020"/>
                 </a:solidFill>
                 <a:latin typeface="Arial"/>
               </a:rPr>
-              <a:t>Sundararajan, Taly &amp; Yan, Axiomatic Attribution for Deep Networks, ICML 2017 (Integrated Gradients)</a:t>
+              <a:t>MITRE ATT&amp;CK Enterprise matrix (attack.mitre.org); NCIIPC (nciipc.gov.in)</a:t>
+            </a:r>
+          </a:p>
+          <a:p>
+            <a:pPr marL="0" indent="0">
+              <a:spcBef>
+                <a:spcPts val="900"/>
+              </a:spcBef>
+              <a:buNone/>
+            </a:pPr>
+            <a:r>
+              <a:rPr sz="1450" b="1">
+                <a:solidFill>
+                  <a:srgbClr val="1F4E9A"/>
+                </a:solidFill>
+                <a:latin typeface="Arial"/>
+              </a:rPr>
+              <a:t>Datasets: all seven named in the PS</a:t>
             </a:r>
           </a:p>
           <a:p>
             <a:pPr marL="457200" indent="-228600">
               <a:spcBef>
-                <a:spcPts val="200"/>
+                <a:spcPts val="300"/>
               </a:spcBef>
               <a:buFont typeface="Arial"/>
               <a:buChar char="•"/>
             </a:pPr>
             <a:r>
-              <a:rPr sz="1550" b="1">
+              <a:rPr sz="1300" b="1">
                 <a:solidFill>
                   <a:srgbClr val="202020"/>
                 </a:solidFill>
                 <a:latin typeface="Arial"/>
               </a:rPr>
-              <a:t>Attack stages: </a:t>
-            </a:r>
-            <a:r>
-              <a:rPr sz="1550" b="0">
+              <a:t/>
+            </a:r>
+            <a:r>
+              <a:rPr sz="1300" b="0">
                 <a:solidFill>
                   <a:srgbClr val="202020"/>
                 </a:solidFill>
                 <a:latin typeface="Arial"/>
               </a:rPr>
-              <a:t>MITRE ATT&amp;CK Enterprise matrix, attack.mitre.org</a:t>
+              <a:t>CTU-13 (Garcia et al., 2014) · CIC-IDS2017 (Sharafaldin et al., 2018) · CSE-CIC-IDS2018 (CIC &amp; AWS, 2018) · UNSW-NB15 (Moustafa &amp; Slay, 2015)</a:t>
             </a:r>
           </a:p>
           <a:p>
             <a:pPr marL="457200" indent="-228600">
               <a:spcBef>
-                <a:spcPts val="200"/>
+                <a:spcPts val="300"/>
               </a:spcBef>
               <a:buFont typeface="Arial"/>
               <a:buChar char="•"/>
             </a:pPr>
             <a:r>
-              <a:rPr sz="1550" b="1">
+              <a:rPr sz="1300" b="1">
                 <a:solidFill>
                   <a:srgbClr val="202020"/>
                 </a:solidFill>
                 <a:latin typeface="Arial"/>
               </a:rPr>
-              <a:t>Datasets: </a:t>
-            </a:r>
-            <a:r>
-              <a:rPr sz="1550" b="0">
+              <a:t/>
+            </a:r>
+            <a:r>
+              <a:rPr sz="1300" b="0">
                 <a:solidFill>
                   <a:srgbClr val="202020"/>
                 </a:solidFill>
                 <a:latin typeface="Arial"/>
               </a:rPr>
-              <a:t>CTU-13 (Garcia et al., 2014); CIC-IDS2017 (Sharafaldin et al., 2018); CSE-CIC-IDS2018 (CIC &amp; AWS, 2018); UNSW-NB15 (Moustafa &amp; Slay, 2015)</a:t>
+              <a:t>LANL cyber1 (Kent, 2015) · DARPA 1999 (Lippmann et al., 2000) · CICIoT2023 (Neto et al., 2023)</a:t>
+            </a:r>
+          </a:p>
+          <a:p>
+            <a:pPr marL="0" indent="0">
+              <a:spcBef>
+                <a:spcPts val="900"/>
+              </a:spcBef>
+              <a:buNone/>
+            </a:pPr>
+            <a:r>
+              <a:rPr sz="1450" b="1">
+                <a:solidFill>
+                  <a:srgbClr val="1F4E9A"/>
+                </a:solidFill>
+                <a:latin typeface="Arial"/>
+              </a:rPr>
+              <a:t>Our work</a:t>
             </a:r>
           </a:p>
           <a:p>
             <a:pPr marL="457200" indent="-228600">
               <a:spcBef>
-                <a:spcPts val="200"/>
+                <a:spcPts val="300"/>
               </a:spcBef>
               <a:buFont typeface="Arial"/>
               <a:buChar char="•"/>
             </a:pPr>
             <a:r>
-              <a:rPr sz="1550" b="1">
+              <a:rPr sz="1300" b="1">
                 <a:solidFill>
                   <a:srgbClr val="202020"/>
                 </a:solidFill>
                 <a:latin typeface="Arial"/>
               </a:rPr>
-              <a:t/>
-            </a:r>
-            <a:r>
-              <a:rPr sz="1550" b="0">
+              <a:t>Source code, weights, benchmark: </a:t>
+            </a:r>
+            <a:r>
+              <a:rPr sz="1300" b="0">
                 <a:solidFill>
                   <a:srgbClr val="202020"/>
                 </a:solidFill>
                 <a:latin typeface="Arial"/>
-              </a:rPr>
-              <a:t>LANL cyber1 (Kent, 2015); DARPA 1999 (Lippmann et al., 2000); CICIoT2023 (Neto et al., 2023)</a:t>
+                <a:hlinkClick r:id="rId4"/>
+              </a:rPr>
+              <a:t>https://github.com/NAMAN-THAKUR-1944/SIH2026-SIH26153-VIGHNAX</a:t>
             </a:r>
           </a:p>
           <a:p>
             <a:pPr marL="457200" indent="-228600">
               <a:spcBef>
-                <a:spcPts val="200"/>
+                <a:spcPts val="300"/>
               </a:spcBef>
               <a:buFont typeface="Arial"/>
               <a:buChar char="•"/>
             </a:pPr>
             <a:r>
-              <a:rPr sz="1550" b="1">
+              <a:rPr sz="1300" b="1">
                 <a:solidFill>
                   <a:srgbClr val="202020"/>
                 </a:solidFill>
                 <a:latin typeface="Arial"/>
               </a:rPr>
-              <a:t>Guidance in the PS: </a:t>
-            </a:r>
-            <a:r>
-              <a:rPr sz="1550" b="0">
+              <a:t>Demo video (2 min): </a:t>
+            </a:r>
+            <a:r>
+              <a:rPr sz="1300" b="0">
                 <a:solidFill>
                   <a:srgbClr val="202020"/>
                 </a:solidFill>
                 <a:latin typeface="Arial"/>
-              </a:rPr>
-              <a:t>NCIIPC, nciipc.gov.in</a:t>
+                <a:hlinkClick r:id="rId5"/>
+              </a:rPr>
+              <a:t>https://youtu.be/pPTe-d_TByU</a:t>
             </a:r>
           </a:p>
           <a:p>
             <a:pPr marL="457200" indent="-228600">
               <a:spcBef>
-                <a:spcPts val="200"/>
+                <a:spcPts val="300"/>
               </a:spcBef>
               <a:buFont typeface="Arial"/>
               <a:buChar char="•"/>
             </a:pPr>
             <a:r>
-              <a:rPr sz="1550" b="1">
+              <a:rPr sz="1300" b="1">
                 <a:solidFill>
                   <a:srgbClr val="202020"/>
                 </a:solidFill>
                 <a:latin typeface="Arial"/>
               </a:rPr>
-              <a:t>Reproducibility: </a:t>
-            </a:r>
-            <a:r>
-              <a:rPr sz="1550" b="0">
+              <a:t>Reproducible: </a:t>
+            </a:r>
+            <a:r>
+              <a:rPr sz="1300" b="0">
                 <a:solidFill>
                   <a:srgbClr val="202020"/>
                 </a:solidFill>
@@ -9265,6 +9764,252 @@
           </a:prstGeom>
         </p:spPr>
       </p:pic>
+      <p:sp>
+        <p:nvSpPr>
+          <p:cNvPr id="17411" name="Rounded Rectangle 17410"/>
+          <p:cNvSpPr/>
+          <p:nvPr/>
+        </p:nvSpPr>
+        <p:spPr>
+          <a:xfrm>
+            <a:off x="8732520" y="1234440"/>
+            <a:ext cx="3063240" cy="2377440"/>
+          </a:xfrm>
+          <a:prstGeom prst="roundRect">
+            <a:avLst>
+              <a:gd name="adj" fmla="val 7000"/>
+            </a:avLst>
+          </a:prstGeom>
+          <a:solidFill>
+            <a:srgbClr val="EEF3FA"/>
+          </a:solidFill>
+          <a:ln>
+            <a:noFill/>
+          </a:ln>
+          <a:effectLst/>
+        </p:spPr>
+        <p:style>
+          <a:lnRef idx="1">
+            <a:schemeClr val="accent1"/>
+          </a:lnRef>
+          <a:fillRef idx="3">
+            <a:schemeClr val="accent1"/>
+          </a:fillRef>
+          <a:effectRef idx="2">
+            <a:schemeClr val="accent1"/>
+          </a:effectRef>
+          <a:fontRef idx="minor">
+            <a:schemeClr val="lt1"/>
+          </a:fontRef>
+        </p:style>
+        <p:txBody>
+          <a:bodyPr rtlCol="0" anchor="ctr" wrap="square" lIns="128016" rIns="128016" tIns="64008" bIns="64008"/>
+          <a:lstStyle/>
+          <a:p>
+            <a:pPr algn="ctr"/>
+          </a:p>
+        </p:txBody>
+      </p:sp>
+      <p:pic>
+        <p:nvPicPr>
+          <p:cNvPr id="17412" name="Picture 17411" descr="qr_source.png">
+            <a:hlinkClick r:id="rId4"/>
+          </p:cNvPr>
+          <p:cNvPicPr>
+            <a:picLocks noChangeAspect="1"/>
+          </p:cNvPicPr>
+          <p:nvPr/>
+        </p:nvPicPr>
+        <p:blipFill>
+          <a:blip r:embed="rId6"/>
+          <a:stretch>
+            <a:fillRect/>
+          </a:stretch>
+        </p:blipFill>
+        <p:spPr>
+          <a:xfrm>
+            <a:off x="9464040" y="1344168"/>
+            <a:ext cx="1600200" cy="1600200"/>
+          </a:xfrm>
+          <a:prstGeom prst="rect">
+            <a:avLst/>
+          </a:prstGeom>
+        </p:spPr>
+      </p:pic>
+      <p:sp>
+        <p:nvSpPr>
+          <p:cNvPr id="17413" name="TextBox 17412"/>
+          <p:cNvSpPr txBox="1"/>
+          <p:nvPr/>
+        </p:nvSpPr>
+        <p:spPr>
+          <a:xfrm>
+            <a:off x="8732520" y="2971800"/>
+            <a:ext cx="3063240" cy="594360"/>
+          </a:xfrm>
+          <a:prstGeom prst="rect">
+            <a:avLst/>
+          </a:prstGeom>
+          <a:noFill/>
+        </p:spPr>
+        <p:txBody>
+          <a:bodyPr wrap="square">
+            <a:spAutoFit/>
+          </a:bodyPr>
+          <a:lstStyle/>
+          <a:p>
+            <a:pPr marL="0" indent="0" algn="ctr">
+              <a:buNone/>
+            </a:pPr>
+            <a:r>
+              <a:rPr sz="1400" b="1">
+                <a:solidFill>
+                  <a:srgbClr val="1F4E9A"/>
+                </a:solidFill>
+                <a:latin typeface="Arial"/>
+              </a:rPr>
+              <a:t>Source code</a:t>
+            </a:r>
+          </a:p>
+          <a:p>
+            <a:pPr marL="0" indent="0" algn="ctr">
+              <a:buNone/>
+            </a:pPr>
+            <a:r>
+              <a:rPr sz="1050" b="0">
+                <a:solidFill>
+                  <a:srgbClr val="555555"/>
+                </a:solidFill>
+                <a:latin typeface="Arial"/>
+              </a:rPr>
+              <a:t>GitHub · weights · benchmark</a:t>
+            </a:r>
+          </a:p>
+        </p:txBody>
+      </p:sp>
+      <p:sp>
+        <p:nvSpPr>
+          <p:cNvPr id="17414" name="Rounded Rectangle 17413"/>
+          <p:cNvSpPr/>
+          <p:nvPr/>
+        </p:nvSpPr>
+        <p:spPr>
+          <a:xfrm>
+            <a:off x="8732520" y="3749039"/>
+            <a:ext cx="3063240" cy="2377440"/>
+          </a:xfrm>
+          <a:prstGeom prst="roundRect">
+            <a:avLst>
+              <a:gd name="adj" fmla="val 7000"/>
+            </a:avLst>
+          </a:prstGeom>
+          <a:solidFill>
+            <a:srgbClr val="EEF3FA"/>
+          </a:solidFill>
+          <a:ln>
+            <a:noFill/>
+          </a:ln>
+          <a:effectLst/>
+        </p:spPr>
+        <p:style>
+          <a:lnRef idx="1">
+            <a:schemeClr val="accent1"/>
+          </a:lnRef>
+          <a:fillRef idx="3">
+            <a:schemeClr val="accent1"/>
+          </a:fillRef>
+          <a:effectRef idx="2">
+            <a:schemeClr val="accent1"/>
+          </a:effectRef>
+          <a:fontRef idx="minor">
+            <a:schemeClr val="lt1"/>
+          </a:fontRef>
+        </p:style>
+        <p:txBody>
+          <a:bodyPr rtlCol="0" anchor="ctr" wrap="square" lIns="128016" rIns="128016" tIns="64008" bIns="64008"/>
+          <a:lstStyle/>
+          <a:p>
+            <a:pPr algn="ctr"/>
+          </a:p>
+        </p:txBody>
+      </p:sp>
+      <p:pic>
+        <p:nvPicPr>
+          <p:cNvPr id="17415" name="Picture 17414" descr="qr_video.png">
+            <a:hlinkClick r:id="rId5"/>
+          </p:cNvPr>
+          <p:cNvPicPr>
+            <a:picLocks noChangeAspect="1"/>
+          </p:cNvPicPr>
+          <p:nvPr/>
+        </p:nvPicPr>
+        <p:blipFill>
+          <a:blip r:embed="rId7"/>
+          <a:stretch>
+            <a:fillRect/>
+          </a:stretch>
+        </p:blipFill>
+        <p:spPr>
+          <a:xfrm>
+            <a:off x="9464040" y="3858768"/>
+            <a:ext cx="1600200" cy="1600200"/>
+          </a:xfrm>
+          <a:prstGeom prst="rect">
+            <a:avLst/>
+          </a:prstGeom>
+        </p:spPr>
+      </p:pic>
+      <p:sp>
+        <p:nvSpPr>
+          <p:cNvPr id="17416" name="TextBox 17415"/>
+          <p:cNvSpPr txBox="1"/>
+          <p:nvPr/>
+        </p:nvSpPr>
+        <p:spPr>
+          <a:xfrm>
+            <a:off x="8732520" y="5486400"/>
+            <a:ext cx="3063240" cy="594360"/>
+          </a:xfrm>
+          <a:prstGeom prst="rect">
+            <a:avLst/>
+          </a:prstGeom>
+          <a:noFill/>
+        </p:spPr>
+        <p:txBody>
+          <a:bodyPr wrap="square">
+            <a:spAutoFit/>
+          </a:bodyPr>
+          <a:lstStyle/>
+          <a:p>
+            <a:pPr marL="0" indent="0" algn="ctr">
+              <a:buNone/>
+            </a:pPr>
+            <a:r>
+              <a:rPr sz="1400" b="1">
+                <a:solidFill>
+                  <a:srgbClr val="1F4E9A"/>
+                </a:solidFill>
+                <a:latin typeface="Arial"/>
+              </a:rPr>
+              <a:t>Demo video</a:t>
+            </a:r>
+          </a:p>
+          <a:p>
+            <a:pPr marL="0" indent="0" algn="ctr">
+              <a:buNone/>
+            </a:pPr>
+            <a:r>
+              <a:rPr sz="1050" b="0">
+                <a:solidFill>
+                  <a:srgbClr val="555555"/>
+                </a:solidFill>
+                <a:latin typeface="Arial"/>
+              </a:rPr>
+              <a:t>YouTube · 2 minutes</a:t>
+            </a:r>
+          </a:p>
+        </p:txBody>
+      </p:sp>
     </p:spTree>
     <p:extLst>
       <p:ext uri="{BB962C8B-B14F-4D97-AF65-F5344CB8AC3E}">

</xml_diff>